<commit_message>
feat(ui): complete cinematic redesign with React, Vite, Tailwind v4 and FastAPI Render deployment
</commit_message>
<xml_diff>
--- a/presentation/EveWatch.pptx
+++ b/presentation/EveWatch.pptx
@@ -4,22 +4,25 @@
   <p:sldMasterIdLst>
     <p:sldMasterId id="2147483648" r:id="rId1"/>
   </p:sldMasterIdLst>
+  <p:notesMasterIdLst>
+    <p:notesMasterId r:id="rId15"/>
+  </p:notesMasterIdLst>
   <p:sldIdLst>
-    <p:sldId id="256" r:id="rId7"/>
-    <p:sldId id="257" r:id="rId9"/>
-    <p:sldId id="258" r:id="rId10"/>
-    <p:sldId id="259" r:id="rId11"/>
-    <p:sldId id="260" r:id="rId12"/>
-    <p:sldId id="261" r:id="rId13"/>
-    <p:sldId id="262" r:id="rId14"/>
-    <p:sldId id="263" r:id="rId15"/>
-    <p:sldId id="264" r:id="rId16"/>
-    <p:sldId id="265" r:id="rId17"/>
-    <p:sldId id="266" r:id="rId18"/>
-    <p:sldId id="267" r:id="rId19"/>
-    <p:sldId id="268" r:id="rId20"/>
+    <p:sldId id="256" r:id="rId2"/>
+    <p:sldId id="257" r:id="rId3"/>
+    <p:sldId id="258" r:id="rId4"/>
+    <p:sldId id="259" r:id="rId5"/>
+    <p:sldId id="260" r:id="rId6"/>
+    <p:sldId id="261" r:id="rId7"/>
+    <p:sldId id="262" r:id="rId8"/>
+    <p:sldId id="263" r:id="rId9"/>
+    <p:sldId id="264" r:id="rId10"/>
+    <p:sldId id="265" r:id="rId11"/>
+    <p:sldId id="266" r:id="rId12"/>
+    <p:sldId id="267" r:id="rId13"/>
+    <p:sldId id="268" r:id="rId14"/>
   </p:sldIdLst>
-  <p:sldSz cx="12191695" cy="6858000" type="screen4x3"/>
+  <p:sldSz cx="12192000" cy="6858000"/>
   <p:notesSz cx="6858000" cy="9144000"/>
   <p:defaultTextStyle>
     <a:defPPr>
@@ -116,11 +119,27 @@
       </a:defRPr>
     </a:lvl9pPr>
   </p:defaultTextStyle>
+  <p:extLst>
+    <p:ext uri="{EFAFB233-063F-42B5-8137-9DF3F51BA10A}">
+      <p15:sldGuideLst xmlns:p15="http://schemas.microsoft.com/office/powerpoint/2012/main">
+        <p15:guide id="1" orient="horz" pos="2160">
+          <p15:clr>
+            <a:srgbClr val="A4A3A4"/>
+          </p15:clr>
+        </p15:guide>
+        <p15:guide id="2" pos="2880">
+          <p15:clr>
+            <a:srgbClr val="A4A3A4"/>
+          </p15:clr>
+        </p15:guide>
+      </p15:sldGuideLst>
+    </p:ext>
+  </p:extLst>
 </p:presentation>
 </file>
 
 <file path=ppt/notesMasters/notesMaster1.xml><?xml version="1.0" encoding="utf-8"?>
-<p:notesMaster xmlns:a="http://schemas.openxmlformats.org/drawingml/2006/main" xmlns:p="http://schemas.openxmlformats.org/presentationml/2006/main" xmlns:r="http://schemas.openxmlformats.org/officeDocument/2006/relationships">
+<p:notesMaster xmlns:a="http://schemas.openxmlformats.org/drawingml/2006/main" xmlns:r="http://schemas.openxmlformats.org/officeDocument/2006/relationships" xmlns:p="http://schemas.openxmlformats.org/presentationml/2006/main">
   <p:cSld>
     <p:bg>
       <p:bgRef idx="1001">
@@ -141,241 +160,16 @@
           <a:chExt cx="0" cy="0"/>
         </a:xfrm>
       </p:grpSpPr>
-      <p:sp>
-        <p:nvSpPr>
-          <p:cNvPr id="2" name="Header Placeholder 1"/>
-          <p:cNvSpPr>
-            <a:spLocks noGrp="1"/>
-          </p:cNvSpPr>
-          <p:nvPr>
-            <p:ph type="hdr" sz="quarter"/>
-          </p:nvPr>
-        </p:nvSpPr>
-        <p:spPr>
-          <a:xfrm>
-            <a:off x="0" y="0"/>
-            <a:ext cx="2971800" cy="457200"/>
-          </a:xfrm>
-          <a:prstGeom prst="rect">
-            <a:avLst/>
-          </a:prstGeom>
-        </p:spPr>
-        <p:txBody>
-          <a:bodyPr vert="horz" lIns="91440" tIns="45720" rIns="91440" bIns="45720" rtlCol="0"/>
-          <a:lstStyle>
-            <a:lvl1pPr algn="l">
-              <a:defRPr sz="1200"/>
-            </a:lvl1pPr>
-          </a:lstStyle>
-          <a:p>
-            <a:endParaRPr lang="en-US"/>
-          </a:p>
-        </p:txBody>
-      </p:sp>
-      <p:sp>
-        <p:nvSpPr>
-          <p:cNvPr id="3" name="Date Placeholder 2"/>
-          <p:cNvSpPr>
-            <a:spLocks noGrp="1"/>
-          </p:cNvSpPr>
-          <p:nvPr>
-            <p:ph type="dt" idx="1"/>
-          </p:nvPr>
-        </p:nvSpPr>
-        <p:spPr>
-          <a:xfrm>
-            <a:off x="3884613" y="0"/>
-            <a:ext cx="2971800" cy="457200"/>
-          </a:xfrm>
-          <a:prstGeom prst="rect">
-            <a:avLst/>
-          </a:prstGeom>
-        </p:spPr>
-        <p:txBody>
-          <a:bodyPr vert="horz" lIns="91440" tIns="45720" rIns="91440" bIns="45720" rtlCol="0"/>
-          <a:lstStyle>
-            <a:lvl1pPr algn="r">
-              <a:defRPr sz="1200"/>
-            </a:lvl1pPr>
-          </a:lstStyle>
-          <a:p>
-            <a:fld id="{0F89C1C7-3DCD-1040-A9CF-14679D8B5DDD}" type="datetimeFigureOut">
-              <a:rPr lang="en-US" smtClean="0"/>
-              <a:t>10/17/16</a:t>
-            </a:fld>
-            <a:endParaRPr lang="en-US"/>
-          </a:p>
-        </p:txBody>
-      </p:sp>
-      <p:sp>
-        <p:nvSpPr>
-          <p:cNvPr id="4" name="Slide Image Placeholder 3"/>
-          <p:cNvSpPr>
-            <a:spLocks noGrp="1" noRot="1" noChangeAspect="1"/>
-          </p:cNvSpPr>
-          <p:nvPr>
-            <p:ph type="sldImg" idx="2"/>
-          </p:nvPr>
-        </p:nvSpPr>
-        <p:spPr>
-          <a:xfrm>
-            <a:off x="1143000" y="685800"/>
-            <a:ext cx="4572000" cy="3429000"/>
-          </a:xfrm>
-          <a:prstGeom prst="rect">
-            <a:avLst/>
-          </a:prstGeom>
-          <a:noFill/>
-          <a:ln w="12700">
-            <a:solidFill>
-              <a:prstClr val="black"/>
-            </a:solidFill>
-          </a:ln>
-        </p:spPr>
-        <p:txBody>
-          <a:bodyPr vert="horz" lIns="91440" tIns="45720" rIns="91440" bIns="45720" rtlCol="0" anchor="ctr"/>
-          <a:lstStyle/>
-          <a:p>
-            <a:endParaRPr lang="en-US"/>
-          </a:p>
-        </p:txBody>
-      </p:sp>
-      <p:sp>
-        <p:nvSpPr>
-          <p:cNvPr id="5" name="Notes Placeholder 4"/>
-          <p:cNvSpPr>
-            <a:spLocks noGrp="1"/>
-          </p:cNvSpPr>
-          <p:nvPr>
-            <p:ph type="body" sz="quarter" idx="3"/>
-          </p:nvPr>
-        </p:nvSpPr>
-        <p:spPr>
-          <a:xfrm>
-            <a:off x="685800" y="4343400"/>
-            <a:ext cx="5486400" cy="4114800"/>
-          </a:xfrm>
-          <a:prstGeom prst="rect">
-            <a:avLst/>
-          </a:prstGeom>
-        </p:spPr>
-        <p:txBody>
-          <a:bodyPr vert="horz" lIns="91440" tIns="45720" rIns="91440" bIns="45720" rtlCol="0"/>
-          <a:lstStyle/>
-          <a:p>
-            <a:pPr lvl="0"/>
-            <a:r>
-              <a:rPr lang="en-US" smtClean="0"/>
-              <a:t>Click to edit Master text styles</a:t>
-            </a:r>
-          </a:p>
-          <a:p>
-            <a:pPr lvl="1"/>
-            <a:r>
-              <a:rPr lang="en-US" smtClean="0"/>
-              <a:t>Second level</a:t>
-            </a:r>
-          </a:p>
-          <a:p>
-            <a:pPr lvl="2"/>
-            <a:r>
-              <a:rPr lang="en-US" smtClean="0"/>
-              <a:t>Third level</a:t>
-            </a:r>
-          </a:p>
-          <a:p>
-            <a:pPr lvl="3"/>
-            <a:r>
-              <a:rPr lang="en-US" smtClean="0"/>
-              <a:t>Fourth level</a:t>
-            </a:r>
-          </a:p>
-          <a:p>
-            <a:pPr lvl="4"/>
-            <a:r>
-              <a:rPr lang="en-US" smtClean="0"/>
-              <a:t>Fifth level</a:t>
-            </a:r>
-            <a:endParaRPr lang="en-US"/>
-          </a:p>
-        </p:txBody>
-      </p:sp>
-      <p:sp>
-        <p:nvSpPr>
-          <p:cNvPr id="6" name="Footer Placeholder 5"/>
-          <p:cNvSpPr>
-            <a:spLocks noGrp="1"/>
-          </p:cNvSpPr>
-          <p:nvPr>
-            <p:ph type="ftr" sz="quarter" idx="4"/>
-          </p:nvPr>
-        </p:nvSpPr>
-        <p:spPr>
-          <a:xfrm>
-            <a:off x="0" y="8685213"/>
-            <a:ext cx="2971800" cy="457200"/>
-          </a:xfrm>
-          <a:prstGeom prst="rect">
-            <a:avLst/>
-          </a:prstGeom>
-        </p:spPr>
-        <p:txBody>
-          <a:bodyPr vert="horz" lIns="91440" tIns="45720" rIns="91440" bIns="45720" rtlCol="0" anchor="b"/>
-          <a:lstStyle>
-            <a:lvl1pPr algn="l">
-              <a:defRPr sz="1200"/>
-            </a:lvl1pPr>
-          </a:lstStyle>
-          <a:p>
-            <a:endParaRPr lang="en-US"/>
-          </a:p>
-        </p:txBody>
-      </p:sp>
-      <p:sp>
-        <p:nvSpPr>
-          <p:cNvPr id="7" name="Slide Number Placeholder 6"/>
-          <p:cNvSpPr>
-            <a:spLocks noGrp="1"/>
-          </p:cNvSpPr>
-          <p:nvPr>
-            <p:ph type="sldNum" sz="quarter" idx="5"/>
-          </p:nvPr>
-        </p:nvSpPr>
-        <p:spPr>
-          <a:xfrm>
-            <a:off x="3884613" y="8685213"/>
-            <a:ext cx="2971800" cy="457200"/>
-          </a:xfrm>
-          <a:prstGeom prst="rect">
-            <a:avLst/>
-          </a:prstGeom>
-        </p:spPr>
-        <p:txBody>
-          <a:bodyPr vert="horz" lIns="91440" tIns="45720" rIns="91440" bIns="45720" rtlCol="0" anchor="b"/>
-          <a:lstStyle>
-            <a:lvl1pPr algn="r">
-              <a:defRPr sz="1200"/>
-            </a:lvl1pPr>
-          </a:lstStyle>
-          <a:p>
-            <a:fld id="{BB5E49A5-4136-284D-997B-48E1D791AD67}" type="slidenum">
-              <a:rPr lang="en-US" smtClean="0"/>
-              <a:t>‹#›</a:t>
-            </a:fld>
-            <a:endParaRPr lang="en-US"/>
-          </a:p>
-        </p:txBody>
-      </p:sp>
     </p:spTree>
     <p:extLst>
       <p:ext uri="{BB962C8B-B14F-4D97-AF65-F5344CB8AC3E}">
-        <p14:creationId xmlns:p14="http://schemas.microsoft.com/office/powerpoint/2010/main" val="2623252185"/>
+        <p14:creationId xmlns:p14="http://schemas.microsoft.com/office/powerpoint/2010/main" val="3531566917"/>
       </p:ext>
     </p:extLst>
   </p:cSld>
   <p:clrMap bg1="lt1" tx1="dk1" bg2="lt2" tx2="dk2" accent1="accent1" accent2="accent2" accent3="accent3" accent4="accent4" accent5="accent5" accent6="accent6" hlink="hlink" folHlink="folHlink"/>
   <p:notesStyle>
-    <a:lvl1pPr marL="0" algn="l" defTabSz="457200" rtl="0" eaLnBrk="1" latinLnBrk="0" hangingPunct="1">
+    <a:lvl1pPr marL="0" algn="l" defTabSz="914400" rtl="0" eaLnBrk="1" latinLnBrk="0" hangingPunct="1">
       <a:defRPr sz="1200" kern="1200">
         <a:solidFill>
           <a:schemeClr val="tx1"/>
@@ -385,7 +179,7 @@
         <a:cs typeface="+mn-cs"/>
       </a:defRPr>
     </a:lvl1pPr>
-    <a:lvl2pPr marL="457200" algn="l" defTabSz="457200" rtl="0" eaLnBrk="1" latinLnBrk="0" hangingPunct="1">
+    <a:lvl2pPr marL="457200" algn="l" defTabSz="914400" rtl="0" eaLnBrk="1" latinLnBrk="0" hangingPunct="1">
       <a:defRPr sz="1200" kern="1200">
         <a:solidFill>
           <a:schemeClr val="tx1"/>
@@ -395,7 +189,7 @@
         <a:cs typeface="+mn-cs"/>
       </a:defRPr>
     </a:lvl2pPr>
-    <a:lvl3pPr marL="914400" algn="l" defTabSz="457200" rtl="0" eaLnBrk="1" latinLnBrk="0" hangingPunct="1">
+    <a:lvl3pPr marL="914400" algn="l" defTabSz="914400" rtl="0" eaLnBrk="1" latinLnBrk="0" hangingPunct="1">
       <a:defRPr sz="1200" kern="1200">
         <a:solidFill>
           <a:schemeClr val="tx1"/>
@@ -405,7 +199,7 @@
         <a:cs typeface="+mn-cs"/>
       </a:defRPr>
     </a:lvl3pPr>
-    <a:lvl4pPr marL="1371600" algn="l" defTabSz="457200" rtl="0" eaLnBrk="1" latinLnBrk="0" hangingPunct="1">
+    <a:lvl4pPr marL="1371600" algn="l" defTabSz="914400" rtl="0" eaLnBrk="1" latinLnBrk="0" hangingPunct="1">
       <a:defRPr sz="1200" kern="1200">
         <a:solidFill>
           <a:schemeClr val="tx1"/>
@@ -415,7 +209,7 @@
         <a:cs typeface="+mn-cs"/>
       </a:defRPr>
     </a:lvl4pPr>
-    <a:lvl5pPr marL="1828800" algn="l" defTabSz="457200" rtl="0" eaLnBrk="1" latinLnBrk="0" hangingPunct="1">
+    <a:lvl5pPr marL="1828800" algn="l" defTabSz="914400" rtl="0" eaLnBrk="1" latinLnBrk="0" hangingPunct="1">
       <a:defRPr sz="1200" kern="1200">
         <a:solidFill>
           <a:schemeClr val="tx1"/>
@@ -425,7 +219,7 @@
         <a:cs typeface="+mn-cs"/>
       </a:defRPr>
     </a:lvl5pPr>
-    <a:lvl6pPr marL="2286000" algn="l" defTabSz="457200" rtl="0" eaLnBrk="1" latinLnBrk="0" hangingPunct="1">
+    <a:lvl6pPr marL="2286000" algn="l" defTabSz="914400" rtl="0" eaLnBrk="1" latinLnBrk="0" hangingPunct="1">
       <a:defRPr sz="1200" kern="1200">
         <a:solidFill>
           <a:schemeClr val="tx1"/>
@@ -435,7 +229,7 @@
         <a:cs typeface="+mn-cs"/>
       </a:defRPr>
     </a:lvl6pPr>
-    <a:lvl7pPr marL="2743200" algn="l" defTabSz="457200" rtl="0" eaLnBrk="1" latinLnBrk="0" hangingPunct="1">
+    <a:lvl7pPr marL="2743200" algn="l" defTabSz="914400" rtl="0" eaLnBrk="1" latinLnBrk="0" hangingPunct="1">
       <a:defRPr sz="1200" kern="1200">
         <a:solidFill>
           <a:schemeClr val="tx1"/>
@@ -445,7 +239,7 @@
         <a:cs typeface="+mn-cs"/>
       </a:defRPr>
     </a:lvl7pPr>
-    <a:lvl8pPr marL="3200400" algn="l" defTabSz="457200" rtl="0" eaLnBrk="1" latinLnBrk="0" hangingPunct="1">
+    <a:lvl8pPr marL="3200400" algn="l" defTabSz="914400" rtl="0" eaLnBrk="1" latinLnBrk="0" hangingPunct="1">
       <a:defRPr sz="1200" kern="1200">
         <a:solidFill>
           <a:schemeClr val="tx1"/>
@@ -455,7 +249,7 @@
         <a:cs typeface="+mn-cs"/>
       </a:defRPr>
     </a:lvl8pPr>
-    <a:lvl9pPr marL="3657600" algn="l" defTabSz="457200" rtl="0" eaLnBrk="1" latinLnBrk="0" hangingPunct="1">
+    <a:lvl9pPr marL="3657600" algn="l" defTabSz="914400" rtl="0" eaLnBrk="1" latinLnBrk="0" hangingPunct="1">
       <a:defRPr sz="1200" kern="1200">
         <a:solidFill>
           <a:schemeClr val="tx1"/>
@@ -470,7 +264,7 @@
 </file>
 
 <file path=ppt/notesSlides/notesSlide1.xml><?xml version="1.0" encoding="utf-8"?>
-<p:notes xmlns:a="http://schemas.openxmlformats.org/drawingml/2006/main" xmlns:p="http://schemas.openxmlformats.org/presentationml/2006/main" xmlns:r="http://schemas.openxmlformats.org/officeDocument/2006/relationships">
+<p:notes xmlns:a="http://schemas.openxmlformats.org/drawingml/2006/main" xmlns:r="http://schemas.openxmlformats.org/officeDocument/2006/relationships" xmlns:p="http://schemas.openxmlformats.org/presentationml/2006/main">
   <p:cSld>
     <p:spTree>
       <p:nvGrpSpPr>
@@ -490,43 +284,43 @@
         <p:nvSpPr>
           <p:cNvPr id="2" name="Slide Image Placeholder 1"/>
           <p:cNvSpPr>
+            <a:spLocks noGrp="1" noRot="1" noChangeAspect="1"/>
+          </p:cNvSpPr>
+          <p:nvPr>
+            <p:ph type="sldImg" idx="2"/>
+          </p:nvPr>
+        </p:nvSpPr>
+        <p:spPr/>
+      </p:sp>
+      <p:sp>
+        <p:nvSpPr>
+          <p:cNvPr id="3" name="Notes Placeholder 2"/>
+          <p:cNvSpPr>
             <a:spLocks noGrp="1"/>
           </p:cNvSpPr>
           <p:nvPr>
-            <p:ph type="sldImg" idx="2"/>
+            <p:ph type="body" sz="quarter" idx="3"/>
           </p:nvPr>
         </p:nvSpPr>
         <p:spPr/>
-      </p:sp>
-      <p:sp>
-        <p:nvSpPr>
-          <p:cNvPr id="3" name="Notes Placeholder 2"/>
+        <p:txBody>
+          <a:bodyPr/>
+          <a:lstStyle/>
+          <a:p>
+            <a:r>
+              <a:t>Welcome judges! Today I am presenting EveWatch, our project for the Quantum Secure Communication track at Qiskit Fall Fest 2026. EveWatch tackles a fundamental and often overlooked question in Quantum Key Distribution: When Alice and Bob detect transmission errors, can they genuinely distinguish an active eavesdropper from baseline hardware noise? Over the next 10 minutes, I will show our end-to-end Qiskit 2.x implementation, our empirical findings across hundreds of trials, and our working Streamlit prototype.</a:t>
+            </a:r>
+          </a:p>
+        </p:txBody>
+      </p:sp>
+      <p:sp>
+        <p:nvSpPr>
+          <p:cNvPr id="4" name="Slide Number Placeholder 3"/>
           <p:cNvSpPr>
             <a:spLocks noGrp="1"/>
           </p:cNvSpPr>
           <p:nvPr>
-            <p:ph type="body" idx="3" sz="quarter"/>
-          </p:nvPr>
-        </p:nvSpPr>
-        <p:spPr/>
-        <p:txBody>
-          <a:bodyPr/>
-          <a:lstStyle/>
-          <a:p>
-            <a:r>
-              <a:t>Welcome judges! Today I am presenting EveWatch, our project for the Quantum Secure Communication track at Qiskit Fall Fest 2026. EveWatch tackles a fundamental and often overlooked question in Quantum Key Distribution: When Alice and Bob detect transmission errors, can they genuinely distinguish an active eavesdropper from baseline hardware noise? Over the next 10 minutes, I will show our end-to-end Qiskit 2.x implementation, our empirical findings across hundreds of trials, and our working Streamlit prototype.</a:t>
-            </a:r>
-          </a:p>
-        </p:txBody>
-      </p:sp>
-      <p:sp>
-        <p:nvSpPr>
-          <p:cNvPr id="4" name="Slide Number Placeholder 3"/>
-          <p:cNvSpPr>
-            <a:spLocks noGrp="1"/>
-          </p:cNvSpPr>
-          <p:nvPr>
-            <p:ph type="sldNum" idx="5" sz="quarter"/>
+            <p:ph type="sldNum" sz="quarter" idx="5"/>
           </p:nvPr>
         </p:nvSpPr>
         <p:spPr/>
@@ -540,7 +334,7 @@
 </file>
 
 <file path=ppt/notesSlides/notesSlide10.xml><?xml version="1.0" encoding="utf-8"?>
-<p:notes xmlns:a="http://schemas.openxmlformats.org/drawingml/2006/main" xmlns:p="http://schemas.openxmlformats.org/presentationml/2006/main" xmlns:r="http://schemas.openxmlformats.org/officeDocument/2006/relationships">
+<p:notes xmlns:a="http://schemas.openxmlformats.org/drawingml/2006/main" xmlns:r="http://schemas.openxmlformats.org/officeDocument/2006/relationships" xmlns:p="http://schemas.openxmlformats.org/presentationml/2006/main">
   <p:cSld>
     <p:spTree>
       <p:nvGrpSpPr>
@@ -560,43 +354,43 @@
         <p:nvSpPr>
           <p:cNvPr id="2" name="Slide Image Placeholder 1"/>
           <p:cNvSpPr>
+            <a:spLocks noGrp="1" noRot="1" noChangeAspect="1"/>
+          </p:cNvSpPr>
+          <p:nvPr>
+            <p:ph type="sldImg" idx="2"/>
+          </p:nvPr>
+        </p:nvSpPr>
+        <p:spPr/>
+      </p:sp>
+      <p:sp>
+        <p:nvSpPr>
+          <p:cNvPr id="3" name="Notes Placeholder 2"/>
+          <p:cNvSpPr>
             <a:spLocks noGrp="1"/>
           </p:cNvSpPr>
           <p:nvPr>
-            <p:ph type="sldImg" idx="2"/>
+            <p:ph type="body" sz="quarter" idx="3"/>
           </p:nvPr>
         </p:nvSpPr>
         <p:spPr/>
-      </p:sp>
-      <p:sp>
-        <p:nvSpPr>
-          <p:cNvPr id="3" name="Notes Placeholder 2"/>
+        <p:txBody>
+          <a:bodyPr/>
+          <a:lstStyle/>
+          <a:p>
+            <a:r>
+              <a:t>Slide 10 details our interactive Streamlit prototype. It features four dedicated tabs: an interactive transmission step-by-step table, an experiment visualizer, a live One-Time Pad text encryption tool, and an educational explainer. It runs smoothly with streamlit run app.py.</a:t>
+            </a:r>
+          </a:p>
+        </p:txBody>
+      </p:sp>
+      <p:sp>
+        <p:nvSpPr>
+          <p:cNvPr id="4" name="Slide Number Placeholder 3"/>
           <p:cNvSpPr>
             <a:spLocks noGrp="1"/>
           </p:cNvSpPr>
           <p:nvPr>
-            <p:ph type="body" idx="3" sz="quarter"/>
-          </p:nvPr>
-        </p:nvSpPr>
-        <p:spPr/>
-        <p:txBody>
-          <a:bodyPr/>
-          <a:lstStyle/>
-          <a:p>
-            <a:r>
-              <a:t>Slide 10 details our interactive Streamlit prototype. It features four dedicated tabs: an interactive transmission step-by-step table, an experiment visualizer, a live One-Time Pad text encryption tool, and an educational explainer. It runs smoothly with streamlit run app.py.</a:t>
-            </a:r>
-          </a:p>
-        </p:txBody>
-      </p:sp>
-      <p:sp>
-        <p:nvSpPr>
-          <p:cNvPr id="4" name="Slide Number Placeholder 3"/>
-          <p:cNvSpPr>
-            <a:spLocks noGrp="1"/>
-          </p:cNvSpPr>
-          <p:nvPr>
-            <p:ph type="sldNum" idx="5" sz="quarter"/>
+            <p:ph type="sldNum" sz="quarter" idx="5"/>
           </p:nvPr>
         </p:nvSpPr>
         <p:spPr/>
@@ -610,7 +404,7 @@
 </file>
 
 <file path=ppt/notesSlides/notesSlide11.xml><?xml version="1.0" encoding="utf-8"?>
-<p:notes xmlns:a="http://schemas.openxmlformats.org/drawingml/2006/main" xmlns:p="http://schemas.openxmlformats.org/presentationml/2006/main" xmlns:r="http://schemas.openxmlformats.org/officeDocument/2006/relationships">
+<p:notes xmlns:a="http://schemas.openxmlformats.org/drawingml/2006/main" xmlns:r="http://schemas.openxmlformats.org/officeDocument/2006/relationships" xmlns:p="http://schemas.openxmlformats.org/presentationml/2006/main">
   <p:cSld>
     <p:spTree>
       <p:nvGrpSpPr>
@@ -630,43 +424,43 @@
         <p:nvSpPr>
           <p:cNvPr id="2" name="Slide Image Placeholder 1"/>
           <p:cNvSpPr>
+            <a:spLocks noGrp="1" noRot="1" noChangeAspect="1"/>
+          </p:cNvSpPr>
+          <p:nvPr>
+            <p:ph type="sldImg" idx="2"/>
+          </p:nvPr>
+        </p:nvSpPr>
+        <p:spPr/>
+      </p:sp>
+      <p:sp>
+        <p:nvSpPr>
+          <p:cNvPr id="3" name="Notes Placeholder 2"/>
+          <p:cNvSpPr>
             <a:spLocks noGrp="1"/>
           </p:cNvSpPr>
           <p:nvPr>
-            <p:ph type="sldImg" idx="2"/>
+            <p:ph type="body" sz="quarter" idx="3"/>
           </p:nvPr>
         </p:nvSpPr>
         <p:spPr/>
-      </p:sp>
-      <p:sp>
-        <p:nvSpPr>
-          <p:cNvPr id="3" name="Notes Placeholder 2"/>
+        <p:txBody>
+          <a:bodyPr/>
+          <a:lstStyle/>
+          <a:p>
+            <a:r>
+              <a:t>Slide 11 highlights our competitive differentiation for the judges. Unlike generic student projects using legacy APIs and idealized assumptions, EveWatch delivers modern Qiskit 2.x stabilizer performance, multi-tiered hardware noise modeling, continuous adversary fractions, and statistically rigorous sample scaling analysis.</a:t>
+            </a:r>
+          </a:p>
+        </p:txBody>
+      </p:sp>
+      <p:sp>
+        <p:nvSpPr>
+          <p:cNvPr id="4" name="Slide Number Placeholder 3"/>
           <p:cNvSpPr>
             <a:spLocks noGrp="1"/>
           </p:cNvSpPr>
           <p:nvPr>
-            <p:ph type="body" idx="3" sz="quarter"/>
-          </p:nvPr>
-        </p:nvSpPr>
-        <p:spPr/>
-        <p:txBody>
-          <a:bodyPr/>
-          <a:lstStyle/>
-          <a:p>
-            <a:r>
-              <a:t>Slide 11 highlights our competitive differentiation for the judges. Unlike generic student projects using legacy APIs and idealized assumptions, EveWatch delivers modern Qiskit 2.x stabilizer performance, multi-tiered hardware noise modeling, continuous adversary fractions, and statistically rigorous sample scaling analysis.</a:t>
-            </a:r>
-          </a:p>
-        </p:txBody>
-      </p:sp>
-      <p:sp>
-        <p:nvSpPr>
-          <p:cNvPr id="4" name="Slide Number Placeholder 3"/>
-          <p:cNvSpPr>
-            <a:spLocks noGrp="1"/>
-          </p:cNvSpPr>
-          <p:nvPr>
-            <p:ph type="sldNum" idx="5" sz="quarter"/>
+            <p:ph type="sldNum" sz="quarter" idx="5"/>
           </p:nvPr>
         </p:nvSpPr>
         <p:spPr/>
@@ -680,7 +474,7 @@
 </file>
 
 <file path=ppt/notesSlides/notesSlide12.xml><?xml version="1.0" encoding="utf-8"?>
-<p:notes xmlns:a="http://schemas.openxmlformats.org/drawingml/2006/main" xmlns:p="http://schemas.openxmlformats.org/presentationml/2006/main" xmlns:r="http://schemas.openxmlformats.org/officeDocument/2006/relationships">
+<p:notes xmlns:a="http://schemas.openxmlformats.org/drawingml/2006/main" xmlns:r="http://schemas.openxmlformats.org/officeDocument/2006/relationships" xmlns:p="http://schemas.openxmlformats.org/presentationml/2006/main">
   <p:cSld>
     <p:spTree>
       <p:nvGrpSpPr>
@@ -700,43 +494,43 @@
         <p:nvSpPr>
           <p:cNvPr id="2" name="Slide Image Placeholder 1"/>
           <p:cNvSpPr>
+            <a:spLocks noGrp="1" noRot="1" noChangeAspect="1"/>
+          </p:cNvSpPr>
+          <p:nvPr>
+            <p:ph type="sldImg" idx="2"/>
+          </p:nvPr>
+        </p:nvSpPr>
+        <p:spPr/>
+      </p:sp>
+      <p:sp>
+        <p:nvSpPr>
+          <p:cNvPr id="3" name="Notes Placeholder 2"/>
+          <p:cNvSpPr>
             <a:spLocks noGrp="1"/>
           </p:cNvSpPr>
           <p:nvPr>
-            <p:ph type="sldImg" idx="2"/>
+            <p:ph type="body" sz="quarter" idx="3"/>
           </p:nvPr>
         </p:nvSpPr>
         <p:spPr/>
-      </p:sp>
-      <p:sp>
-        <p:nvSpPr>
-          <p:cNvPr id="3" name="Notes Placeholder 2"/>
+        <p:txBody>
+          <a:bodyPr/>
+          <a:lstStyle/>
+          <a:p>
+            <a:r>
+              <a:t>We believe scientific credibility requires acknowledging honest limitations. Our work is simulation-based and focuses on intercept-resend. Looking forward, we have a clear roadmap to incorporate decoy-state protocols, E91 entanglement verification, and hybrid post-quantum cryptography integration.</a:t>
+            </a:r>
+          </a:p>
+        </p:txBody>
+      </p:sp>
+      <p:sp>
+        <p:nvSpPr>
+          <p:cNvPr id="4" name="Slide Number Placeholder 3"/>
           <p:cNvSpPr>
             <a:spLocks noGrp="1"/>
           </p:cNvSpPr>
           <p:nvPr>
-            <p:ph type="body" idx="3" sz="quarter"/>
-          </p:nvPr>
-        </p:nvSpPr>
-        <p:spPr/>
-        <p:txBody>
-          <a:bodyPr/>
-          <a:lstStyle/>
-          <a:p>
-            <a:r>
-              <a:t>We believe scientific credibility requires acknowledging honest limitations. Our work is simulation-based and focuses on intercept-resend. Looking forward, we have a clear roadmap to incorporate decoy-state protocols, E91 entanglement verification, and hybrid post-quantum cryptography integration.</a:t>
-            </a:r>
-          </a:p>
-        </p:txBody>
-      </p:sp>
-      <p:sp>
-        <p:nvSpPr>
-          <p:cNvPr id="4" name="Slide Number Placeholder 3"/>
-          <p:cNvSpPr>
-            <a:spLocks noGrp="1"/>
-          </p:cNvSpPr>
-          <p:nvPr>
-            <p:ph type="sldNum" idx="5" sz="quarter"/>
+            <p:ph type="sldNum" sz="quarter" idx="5"/>
           </p:nvPr>
         </p:nvSpPr>
         <p:spPr/>
@@ -750,7 +544,7 @@
 </file>
 
 <file path=ppt/notesSlides/notesSlide13.xml><?xml version="1.0" encoding="utf-8"?>
-<p:notes xmlns:a="http://schemas.openxmlformats.org/drawingml/2006/main" xmlns:p="http://schemas.openxmlformats.org/presentationml/2006/main" xmlns:r="http://schemas.openxmlformats.org/officeDocument/2006/relationships">
+<p:notes xmlns:a="http://schemas.openxmlformats.org/drawingml/2006/main" xmlns:r="http://schemas.openxmlformats.org/officeDocument/2006/relationships" xmlns:p="http://schemas.openxmlformats.org/presentationml/2006/main">
   <p:cSld>
     <p:spTree>
       <p:nvGrpSpPr>
@@ -770,43 +564,43 @@
         <p:nvSpPr>
           <p:cNvPr id="2" name="Slide Image Placeholder 1"/>
           <p:cNvSpPr>
+            <a:spLocks noGrp="1" noRot="1" noChangeAspect="1"/>
+          </p:cNvSpPr>
+          <p:nvPr>
+            <p:ph type="sldImg" idx="2"/>
+          </p:nvPr>
+        </p:nvSpPr>
+        <p:spPr/>
+      </p:sp>
+      <p:sp>
+        <p:nvSpPr>
+          <p:cNvPr id="3" name="Notes Placeholder 2"/>
+          <p:cNvSpPr>
             <a:spLocks noGrp="1"/>
           </p:cNvSpPr>
           <p:nvPr>
-            <p:ph type="sldImg" idx="2"/>
+            <p:ph type="body" sz="quarter" idx="3"/>
           </p:nvPr>
         </p:nvSpPr>
         <p:spPr/>
-      </p:sp>
-      <p:sp>
-        <p:nvSpPr>
-          <p:cNvPr id="3" name="Notes Placeholder 2"/>
+        <p:txBody>
+          <a:bodyPr/>
+          <a:lstStyle/>
+          <a:p>
+            <a:r>
+              <a:t>To conclude: EveWatch proves that while physical errors conflate eavesdropping and hardware noise, statistical sample scaling provides the key to reliable, provable quantum communication. Our full codebase, tests, figures, and Streamlit app are open-source on GitHub at github.com/Ayush-web28/EveWatch. Thank you, and I look forward to your questions!</a:t>
+            </a:r>
+          </a:p>
+        </p:txBody>
+      </p:sp>
+      <p:sp>
+        <p:nvSpPr>
+          <p:cNvPr id="4" name="Slide Number Placeholder 3"/>
           <p:cNvSpPr>
             <a:spLocks noGrp="1"/>
           </p:cNvSpPr>
           <p:nvPr>
-            <p:ph type="body" idx="3" sz="quarter"/>
-          </p:nvPr>
-        </p:nvSpPr>
-        <p:spPr/>
-        <p:txBody>
-          <a:bodyPr/>
-          <a:lstStyle/>
-          <a:p>
-            <a:r>
-              <a:t>To conclude: EveWatch proves that while physical errors conflate eavesdropping and hardware noise, statistical sample scaling provides the key to reliable, provable quantum communication. Our full codebase, tests, figures, and Streamlit app are open-source on GitHub at github.com/Ayush-web28/EveWatch. Thank you, and I look forward to your questions!</a:t>
-            </a:r>
-          </a:p>
-        </p:txBody>
-      </p:sp>
-      <p:sp>
-        <p:nvSpPr>
-          <p:cNvPr id="4" name="Slide Number Placeholder 3"/>
-          <p:cNvSpPr>
-            <a:spLocks noGrp="1"/>
-          </p:cNvSpPr>
-          <p:nvPr>
-            <p:ph type="sldNum" idx="5" sz="quarter"/>
+            <p:ph type="sldNum" sz="quarter" idx="5"/>
           </p:nvPr>
         </p:nvSpPr>
         <p:spPr/>
@@ -820,7 +614,7 @@
 </file>
 
 <file path=ppt/notesSlides/notesSlide2.xml><?xml version="1.0" encoding="utf-8"?>
-<p:notes xmlns:a="http://schemas.openxmlformats.org/drawingml/2006/main" xmlns:p="http://schemas.openxmlformats.org/presentationml/2006/main" xmlns:r="http://schemas.openxmlformats.org/officeDocument/2006/relationships">
+<p:notes xmlns:a="http://schemas.openxmlformats.org/drawingml/2006/main" xmlns:r="http://schemas.openxmlformats.org/officeDocument/2006/relationships" xmlns:p="http://schemas.openxmlformats.org/presentationml/2006/main">
   <p:cSld>
     <p:spTree>
       <p:nvGrpSpPr>
@@ -840,43 +634,43 @@
         <p:nvSpPr>
           <p:cNvPr id="2" name="Slide Image Placeholder 1"/>
           <p:cNvSpPr>
+            <a:spLocks noGrp="1" noRot="1" noChangeAspect="1"/>
+          </p:cNvSpPr>
+          <p:nvPr>
+            <p:ph type="sldImg" idx="2"/>
+          </p:nvPr>
+        </p:nvSpPr>
+        <p:spPr/>
+      </p:sp>
+      <p:sp>
+        <p:nvSpPr>
+          <p:cNvPr id="3" name="Notes Placeholder 2"/>
+          <p:cNvSpPr>
             <a:spLocks noGrp="1"/>
           </p:cNvSpPr>
           <p:nvPr>
-            <p:ph type="sldImg" idx="2"/>
+            <p:ph type="body" sz="quarter" idx="3"/>
           </p:nvPr>
         </p:nvSpPr>
         <p:spPr/>
-      </p:sp>
-      <p:sp>
-        <p:nvSpPr>
-          <p:cNvPr id="3" name="Notes Placeholder 2"/>
+        <p:txBody>
+          <a:bodyPr/>
+          <a:lstStyle/>
+          <a:p>
+            <a:r>
+              <a:t>Slide 2 sets the foundation. We explain why classical cryptography faces an existential deadline from Shor's algorithm. Quantum Key Distribution solves this by grounding security in the No-Cloning Theorem and Heisenberg Uncertainty Principle. Any eavesdropping creates physical disturbances that Alice and Bob can observe directly in the Quantum Bit Error Rate.</a:t>
+            </a:r>
+          </a:p>
+        </p:txBody>
+      </p:sp>
+      <p:sp>
+        <p:nvSpPr>
+          <p:cNvPr id="4" name="Slide Number Placeholder 3"/>
           <p:cNvSpPr>
             <a:spLocks noGrp="1"/>
           </p:cNvSpPr>
           <p:nvPr>
-            <p:ph type="body" idx="3" sz="quarter"/>
-          </p:nvPr>
-        </p:nvSpPr>
-        <p:spPr/>
-        <p:txBody>
-          <a:bodyPr/>
-          <a:lstStyle/>
-          <a:p>
-            <a:r>
-              <a:t>Slide 2 sets the foundation. We explain why classical cryptography faces an existential deadline from Shor's algorithm. Quantum Key Distribution solves this by grounding security in the No-Cloning Theorem and Heisenberg Uncertainty Principle. Any eavesdropping creates physical disturbances that Alice and Bob can observe directly in the Quantum Bit Error Rate.</a:t>
-            </a:r>
-          </a:p>
-        </p:txBody>
-      </p:sp>
-      <p:sp>
-        <p:nvSpPr>
-          <p:cNvPr id="4" name="Slide Number Placeholder 3"/>
-          <p:cNvSpPr>
-            <a:spLocks noGrp="1"/>
-          </p:cNvSpPr>
-          <p:nvPr>
-            <p:ph type="sldNum" idx="5" sz="quarter"/>
+            <p:ph type="sldNum" sz="quarter" idx="5"/>
           </p:nvPr>
         </p:nvSpPr>
         <p:spPr/>
@@ -890,7 +684,7 @@
 </file>
 
 <file path=ppt/notesSlides/notesSlide3.xml><?xml version="1.0" encoding="utf-8"?>
-<p:notes xmlns:a="http://schemas.openxmlformats.org/drawingml/2006/main" xmlns:p="http://schemas.openxmlformats.org/presentationml/2006/main" xmlns:r="http://schemas.openxmlformats.org/officeDocument/2006/relationships">
+<p:notes xmlns:a="http://schemas.openxmlformats.org/drawingml/2006/main" xmlns:r="http://schemas.openxmlformats.org/officeDocument/2006/relationships" xmlns:p="http://schemas.openxmlformats.org/presentationml/2006/main">
   <p:cSld>
     <p:spTree>
       <p:nvGrpSpPr>
@@ -910,43 +704,43 @@
         <p:nvSpPr>
           <p:cNvPr id="2" name="Slide Image Placeholder 1"/>
           <p:cNvSpPr>
+            <a:spLocks noGrp="1" noRot="1" noChangeAspect="1"/>
+          </p:cNvSpPr>
+          <p:nvPr>
+            <p:ph type="sldImg" idx="2"/>
+          </p:nvPr>
+        </p:nvSpPr>
+        <p:spPr/>
+      </p:sp>
+      <p:sp>
+        <p:nvSpPr>
+          <p:cNvPr id="3" name="Notes Placeholder 2"/>
+          <p:cNvSpPr>
             <a:spLocks noGrp="1"/>
           </p:cNvSpPr>
           <p:nvPr>
-            <p:ph type="sldImg" idx="2"/>
+            <p:ph type="body" sz="quarter" idx="3"/>
           </p:nvPr>
         </p:nvSpPr>
         <p:spPr/>
-      </p:sp>
-      <p:sp>
-        <p:nvSpPr>
-          <p:cNvPr id="3" name="Notes Placeholder 2"/>
+        <p:txBody>
+          <a:bodyPr/>
+          <a:lstStyle/>
+          <a:p>
+            <a:r>
+              <a:t>Here is the differentiator that sets EveWatch apart from standard student projects. Most tutorials assume perfect noiseless physics where QBER &gt; 0 immediately flags Eve. In reality, optical fibers and superconducting qubits have natural background noise. If Alice and Bob observe an 8% QBER, is that 16% channel noise, or Eve intercepting 32% of bits? This ambiguity is what EveWatch investigates mathematically and empirically.</a:t>
+            </a:r>
+          </a:p>
+        </p:txBody>
+      </p:sp>
+      <p:sp>
+        <p:nvSpPr>
+          <p:cNvPr id="4" name="Slide Number Placeholder 3"/>
           <p:cNvSpPr>
             <a:spLocks noGrp="1"/>
           </p:cNvSpPr>
           <p:nvPr>
-            <p:ph type="body" idx="3" sz="quarter"/>
-          </p:nvPr>
-        </p:nvSpPr>
-        <p:spPr/>
-        <p:txBody>
-          <a:bodyPr/>
-          <a:lstStyle/>
-          <a:p>
-            <a:r>
-              <a:t>Here is the differentiator that sets EveWatch apart from standard student projects. Most tutorials assume perfect noiseless physics where QBER &gt; 0 immediately flags Eve. In reality, optical fibers and superconducting qubits have natural background noise. If Alice and Bob observe an 8% QBER, is that 16% channel noise, or Eve intercepting 32% of bits? This ambiguity is what EveWatch investigates mathematically and empirically.</a:t>
-            </a:r>
-          </a:p>
-        </p:txBody>
-      </p:sp>
-      <p:sp>
-        <p:nvSpPr>
-          <p:cNvPr id="4" name="Slide Number Placeholder 3"/>
-          <p:cNvSpPr>
-            <a:spLocks noGrp="1"/>
-          </p:cNvSpPr>
-          <p:nvPr>
-            <p:ph type="sldNum" idx="5" sz="quarter"/>
+            <p:ph type="sldNum" sz="quarter" idx="5"/>
           </p:nvPr>
         </p:nvSpPr>
         <p:spPr/>
@@ -960,7 +754,7 @@
 </file>
 
 <file path=ppt/notesSlides/notesSlide4.xml><?xml version="1.0" encoding="utf-8"?>
-<p:notes xmlns:a="http://schemas.openxmlformats.org/drawingml/2006/main" xmlns:p="http://schemas.openxmlformats.org/presentationml/2006/main" xmlns:r="http://schemas.openxmlformats.org/officeDocument/2006/relationships">
+<p:notes xmlns:a="http://schemas.openxmlformats.org/drawingml/2006/main" xmlns:r="http://schemas.openxmlformats.org/officeDocument/2006/relationships" xmlns:p="http://schemas.openxmlformats.org/presentationml/2006/main">
   <p:cSld>
     <p:spTree>
       <p:nvGrpSpPr>
@@ -980,43 +774,43 @@
         <p:nvSpPr>
           <p:cNvPr id="2" name="Slide Image Placeholder 1"/>
           <p:cNvSpPr>
+            <a:spLocks noGrp="1" noRot="1" noChangeAspect="1"/>
+          </p:cNvSpPr>
+          <p:nvPr>
+            <p:ph type="sldImg" idx="2"/>
+          </p:nvPr>
+        </p:nvSpPr>
+        <p:spPr/>
+      </p:sp>
+      <p:sp>
+        <p:nvSpPr>
+          <p:cNvPr id="3" name="Notes Placeholder 2"/>
+          <p:cNvSpPr>
             <a:spLocks noGrp="1"/>
           </p:cNvSpPr>
           <p:nvPr>
-            <p:ph type="sldImg" idx="2"/>
+            <p:ph type="body" sz="quarter" idx="3"/>
           </p:nvPr>
         </p:nvSpPr>
         <p:spPr/>
-      </p:sp>
-      <p:sp>
-        <p:nvSpPr>
-          <p:cNvPr id="3" name="Notes Placeholder 2"/>
+        <p:txBody>
+          <a:bodyPr/>
+          <a:lstStyle/>
+          <a:p>
+            <a:r>
+              <a:t>This slide breaks down the four stages of BB84 in plain language for judges. Alice encodes random bits in conjugate bases. Bob measures in random bases. Sifting discards 50% where bases disagreed. Finally, QBER estimation tests whether the quantum channel was tapped.</a:t>
+            </a:r>
+          </a:p>
+        </p:txBody>
+      </p:sp>
+      <p:sp>
+        <p:nvSpPr>
+          <p:cNvPr id="4" name="Slide Number Placeholder 3"/>
           <p:cNvSpPr>
             <a:spLocks noGrp="1"/>
           </p:cNvSpPr>
           <p:nvPr>
-            <p:ph type="body" idx="3" sz="quarter"/>
-          </p:nvPr>
-        </p:nvSpPr>
-        <p:spPr/>
-        <p:txBody>
-          <a:bodyPr/>
-          <a:lstStyle/>
-          <a:p>
-            <a:r>
-              <a:t>This slide breaks down the four stages of BB84 in plain language for judges. Alice encodes random bits in conjugate bases. Bob measures in random bases. Sifting discards 50% where bases disagreed. Finally, QBER estimation tests whether the quantum channel was tapped.</a:t>
-            </a:r>
-          </a:p>
-        </p:txBody>
-      </p:sp>
-      <p:sp>
-        <p:nvSpPr>
-          <p:cNvPr id="4" name="Slide Number Placeholder 3"/>
-          <p:cNvSpPr>
-            <a:spLocks noGrp="1"/>
-          </p:cNvSpPr>
-          <p:nvPr>
-            <p:ph type="sldNum" idx="5" sz="quarter"/>
+            <p:ph type="sldNum" sz="quarter" idx="5"/>
           </p:nvPr>
         </p:nvSpPr>
         <p:spPr/>
@@ -1030,7 +824,7 @@
 </file>
 
 <file path=ppt/notesSlides/notesSlide5.xml><?xml version="1.0" encoding="utf-8"?>
-<p:notes xmlns:a="http://schemas.openxmlformats.org/drawingml/2006/main" xmlns:p="http://schemas.openxmlformats.org/presentationml/2006/main" xmlns:r="http://schemas.openxmlformats.org/officeDocument/2006/relationships">
+<p:notes xmlns:a="http://schemas.openxmlformats.org/drawingml/2006/main" xmlns:r="http://schemas.openxmlformats.org/officeDocument/2006/relationships" xmlns:p="http://schemas.openxmlformats.org/presentationml/2006/main">
   <p:cSld>
     <p:spTree>
       <p:nvGrpSpPr>
@@ -1050,43 +844,43 @@
         <p:nvSpPr>
           <p:cNvPr id="2" name="Slide Image Placeholder 1"/>
           <p:cNvSpPr>
+            <a:spLocks noGrp="1" noRot="1" noChangeAspect="1"/>
+          </p:cNvSpPr>
+          <p:nvPr>
+            <p:ph type="sldImg" idx="2"/>
+          </p:nvPr>
+        </p:nvSpPr>
+        <p:spPr/>
+      </p:sp>
+      <p:sp>
+        <p:nvSpPr>
+          <p:cNvPr id="3" name="Notes Placeholder 2"/>
+          <p:cNvSpPr>
             <a:spLocks noGrp="1"/>
           </p:cNvSpPr>
           <p:nvPr>
-            <p:ph type="sldImg" idx="2"/>
+            <p:ph type="body" sz="quarter" idx="3"/>
           </p:nvPr>
         </p:nvSpPr>
         <p:spPr/>
-      </p:sp>
-      <p:sp>
-        <p:nvSpPr>
-          <p:cNvPr id="3" name="Notes Placeholder 2"/>
+        <p:txBody>
+          <a:bodyPr/>
+          <a:lstStyle/>
+          <a:p>
+            <a:r>
+              <a:t>Slide 5 illustrates our modular software engineering architecture. We separated protocol execution, adversary modeling, noise generation, and statistical analysis into decoupled, pure modules. Every function has full docstrings and type hints, and all simulation results are pinned by random seeds for strict reproducibility.</a:t>
+            </a:r>
+          </a:p>
+        </p:txBody>
+      </p:sp>
+      <p:sp>
+        <p:nvSpPr>
+          <p:cNvPr id="4" name="Slide Number Placeholder 3"/>
           <p:cNvSpPr>
             <a:spLocks noGrp="1"/>
           </p:cNvSpPr>
           <p:nvPr>
-            <p:ph type="body" idx="3" sz="quarter"/>
-          </p:nvPr>
-        </p:nvSpPr>
-        <p:spPr/>
-        <p:txBody>
-          <a:bodyPr/>
-          <a:lstStyle/>
-          <a:p>
-            <a:r>
-              <a:t>Slide 5 illustrates our modular software engineering architecture. We separated protocol execution, adversary modeling, noise generation, and statistical analysis into decoupled, pure modules. Every function has full docstrings and type hints, and all simulation results are pinned by random seeds for strict reproducibility.</a:t>
-            </a:r>
-          </a:p>
-        </p:txBody>
-      </p:sp>
-      <p:sp>
-        <p:nvSpPr>
-          <p:cNvPr id="4" name="Slide Number Placeholder 3"/>
-          <p:cNvSpPr>
-            <a:spLocks noGrp="1"/>
-          </p:cNvSpPr>
-          <p:nvPr>
-            <p:ph type="sldNum" idx="5" sz="quarter"/>
+            <p:ph type="sldNum" sz="quarter" idx="5"/>
           </p:nvPr>
         </p:nvSpPr>
         <p:spPr/>
@@ -1100,7 +894,7 @@
 </file>
 
 <file path=ppt/notesSlides/notesSlide6.xml><?xml version="1.0" encoding="utf-8"?>
-<p:notes xmlns:a="http://schemas.openxmlformats.org/drawingml/2006/main" xmlns:p="http://schemas.openxmlformats.org/presentationml/2006/main" xmlns:r="http://schemas.openxmlformats.org/officeDocument/2006/relationships">
+<p:notes xmlns:a="http://schemas.openxmlformats.org/drawingml/2006/main" xmlns:r="http://schemas.openxmlformats.org/officeDocument/2006/relationships" xmlns:p="http://schemas.openxmlformats.org/presentationml/2006/main">
   <p:cSld>
     <p:spTree>
       <p:nvGrpSpPr>
@@ -1120,43 +914,43 @@
         <p:nvSpPr>
           <p:cNvPr id="2" name="Slide Image Placeholder 1"/>
           <p:cNvSpPr>
+            <a:spLocks noGrp="1" noRot="1" noChangeAspect="1"/>
+          </p:cNvSpPr>
+          <p:nvPr>
+            <p:ph type="sldImg" idx="2"/>
+          </p:nvPr>
+        </p:nvSpPr>
+        <p:spPr/>
+      </p:sp>
+      <p:sp>
+        <p:nvSpPr>
+          <p:cNvPr id="3" name="Notes Placeholder 2"/>
+          <p:cNvSpPr>
             <a:spLocks noGrp="1"/>
           </p:cNvSpPr>
           <p:nvPr>
-            <p:ph type="sldImg" idx="2"/>
+            <p:ph type="body" sz="quarter" idx="3"/>
           </p:nvPr>
         </p:nvSpPr>
         <p:spPr/>
-      </p:sp>
-      <p:sp>
-        <p:nvSpPr>
-          <p:cNvPr id="3" name="Notes Placeholder 2"/>
+        <p:txBody>
+          <a:bodyPr/>
+          <a:lstStyle/>
+          <a:p>
+            <a:r>
+              <a:t>Here we highlight our Qiskit implementation depth. We don't use deprecated APIs. By leveraging Aer's stabilizer method for Clifford operations, our simulations run in polynomial time O(N). We can simulate 1,000 qubits in 35 milliseconds, allowing us to run 50+ Monte Carlo trials per data point quickly and reliably.</a:t>
+            </a:r>
+          </a:p>
+        </p:txBody>
+      </p:sp>
+      <p:sp>
+        <p:nvSpPr>
+          <p:cNvPr id="4" name="Slide Number Placeholder 3"/>
           <p:cNvSpPr>
             <a:spLocks noGrp="1"/>
           </p:cNvSpPr>
           <p:nvPr>
-            <p:ph type="body" idx="3" sz="quarter"/>
-          </p:nvPr>
-        </p:nvSpPr>
-        <p:spPr/>
-        <p:txBody>
-          <a:bodyPr/>
-          <a:lstStyle/>
-          <a:p>
-            <a:r>
-              <a:t>Here we highlight our Qiskit implementation depth. We don't use deprecated APIs. By leveraging Aer's stabilizer method for Clifford operations, our simulations run in polynomial time O(N). We can simulate 1,000 qubits in 35 milliseconds, allowing us to run 50+ Monte Carlo trials per data point quickly and reliably.</a:t>
-            </a:r>
-          </a:p>
-        </p:txBody>
-      </p:sp>
-      <p:sp>
-        <p:nvSpPr>
-          <p:cNvPr id="4" name="Slide Number Placeholder 3"/>
-          <p:cNvSpPr>
-            <a:spLocks noGrp="1"/>
-          </p:cNvSpPr>
-          <p:nvPr>
-            <p:ph type="sldNum" idx="5" sz="quarter"/>
+            <p:ph type="sldNum" sz="quarter" idx="5"/>
           </p:nvPr>
         </p:nvSpPr>
         <p:spPr/>
@@ -1170,7 +964,7 @@
 </file>
 
 <file path=ppt/notesSlides/notesSlide7.xml><?xml version="1.0" encoding="utf-8"?>
-<p:notes xmlns:a="http://schemas.openxmlformats.org/drawingml/2006/main" xmlns:p="http://schemas.openxmlformats.org/presentationml/2006/main" xmlns:r="http://schemas.openxmlformats.org/officeDocument/2006/relationships">
+<p:notes xmlns:a="http://schemas.openxmlformats.org/drawingml/2006/main" xmlns:r="http://schemas.openxmlformats.org/officeDocument/2006/relationships" xmlns:p="http://schemas.openxmlformats.org/presentationml/2006/main">
   <p:cSld>
     <p:spTree>
       <p:nvGrpSpPr>
@@ -1190,43 +984,43 @@
         <p:nvSpPr>
           <p:cNvPr id="2" name="Slide Image Placeholder 1"/>
           <p:cNvSpPr>
+            <a:spLocks noGrp="1" noRot="1" noChangeAspect="1"/>
+          </p:cNvSpPr>
+          <p:nvPr>
+            <p:ph type="sldImg" idx="2"/>
+          </p:nvPr>
+        </p:nvSpPr>
+        <p:spPr/>
+      </p:sp>
+      <p:sp>
+        <p:nvSpPr>
+          <p:cNvPr id="3" name="Notes Placeholder 2"/>
+          <p:cNvSpPr>
             <a:spLocks noGrp="1"/>
           </p:cNvSpPr>
           <p:nvPr>
-            <p:ph type="sldImg" idx="2"/>
+            <p:ph type="body" sz="quarter" idx="3"/>
           </p:nvPr>
         </p:nvSpPr>
         <p:spPr/>
-      </p:sp>
-      <p:sp>
-        <p:nvSpPr>
-          <p:cNvPr id="3" name="Notes Placeholder 2"/>
+        <p:txBody>
+          <a:bodyPr/>
+          <a:lstStyle/>
+          <a:p>
+            <a:r>
+              <a:t>Slide 7 presents our first empirical results. Our simulation confirms the 25% intercept-resend error rate derived by Bennett and Brassard. Crucially, notice the blind zone: if Eve only taps 40% of qubits, the error rate stays under 11%. This proves that a simple threshold alone is insufficient when background noise exists.</a:t>
+            </a:r>
+          </a:p>
+        </p:txBody>
+      </p:sp>
+      <p:sp>
+        <p:nvSpPr>
+          <p:cNvPr id="4" name="Slide Number Placeholder 3"/>
           <p:cNvSpPr>
             <a:spLocks noGrp="1"/>
           </p:cNvSpPr>
           <p:nvPr>
-            <p:ph type="body" idx="3" sz="quarter"/>
-          </p:nvPr>
-        </p:nvSpPr>
-        <p:spPr/>
-        <p:txBody>
-          <a:bodyPr/>
-          <a:lstStyle/>
-          <a:p>
-            <a:r>
-              <a:t>Slide 7 presents our first empirical results. Our simulation confirms the 25% intercept-resend error rate derived by Bennett and Brassard. Crucially, notice the blind zone: if Eve only taps 40% of qubits, the error rate stays under 11%. This proves that a simple threshold alone is insufficient when background noise exists.</a:t>
-            </a:r>
-          </a:p>
-        </p:txBody>
-      </p:sp>
-      <p:sp>
-        <p:nvSpPr>
-          <p:cNvPr id="4" name="Slide Number Placeholder 3"/>
-          <p:cNvSpPr>
-            <a:spLocks noGrp="1"/>
-          </p:cNvSpPr>
-          <p:nvPr>
-            <p:ph type="sldNum" idx="5" sz="quarter"/>
+            <p:ph type="sldNum" sz="quarter" idx="5"/>
           </p:nvPr>
         </p:nvSpPr>
         <p:spPr/>
@@ -1240,7 +1034,7 @@
 </file>
 
 <file path=ppt/notesSlides/notesSlide8.xml><?xml version="1.0" encoding="utf-8"?>
-<p:notes xmlns:a="http://schemas.openxmlformats.org/drawingml/2006/main" xmlns:p="http://schemas.openxmlformats.org/presentationml/2006/main" xmlns:r="http://schemas.openxmlformats.org/officeDocument/2006/relationships">
+<p:notes xmlns:a="http://schemas.openxmlformats.org/drawingml/2006/main" xmlns:r="http://schemas.openxmlformats.org/officeDocument/2006/relationships" xmlns:p="http://schemas.openxmlformats.org/presentationml/2006/main">
   <p:cSld>
     <p:spTree>
       <p:nvGrpSpPr>
@@ -1260,43 +1054,43 @@
         <p:nvSpPr>
           <p:cNvPr id="2" name="Slide Image Placeholder 1"/>
           <p:cNvSpPr>
+            <a:spLocks noGrp="1" noRot="1" noChangeAspect="1"/>
+          </p:cNvSpPr>
+          <p:nvPr>
+            <p:ph type="sldImg" idx="2"/>
+          </p:nvPr>
+        </p:nvSpPr>
+        <p:spPr/>
+      </p:sp>
+      <p:sp>
+        <p:nvSpPr>
+          <p:cNvPr id="3" name="Notes Placeholder 2"/>
+          <p:cNvSpPr>
             <a:spLocks noGrp="1"/>
           </p:cNvSpPr>
           <p:nvPr>
-            <p:ph type="sldImg" idx="2"/>
+            <p:ph type="body" sz="quarter" idx="3"/>
           </p:nvPr>
         </p:nvSpPr>
         <p:spPr/>
-      </p:sp>
-      <p:sp>
-        <p:nvSpPr>
-          <p:cNvPr id="3" name="Notes Placeholder 2"/>
+        <p:txBody>
+          <a:bodyPr/>
+          <a:lstStyle/>
+          <a:p>
+            <a:r>
+              <a:t>Slide 8 displays our 2D parameter heatmap. This visualizes the joint effect of optical noise and eavesdropping. The dashed cyan contour marks the 11% Shor-Preskill limit. Everything above and to the right must be aborted. Notice the fundamental equifinality: multiple distinct combinations of noise and interception map to identical QBER values.</a:t>
+            </a:r>
+          </a:p>
+        </p:txBody>
+      </p:sp>
+      <p:sp>
+        <p:nvSpPr>
+          <p:cNvPr id="4" name="Slide Number Placeholder 3"/>
           <p:cNvSpPr>
             <a:spLocks noGrp="1"/>
           </p:cNvSpPr>
           <p:nvPr>
-            <p:ph type="body" idx="3" sz="quarter"/>
-          </p:nvPr>
-        </p:nvSpPr>
-        <p:spPr/>
-        <p:txBody>
-          <a:bodyPr/>
-          <a:lstStyle/>
-          <a:p>
-            <a:r>
-              <a:t>Slide 8 displays our 2D parameter heatmap. This visualizes the joint effect of optical noise and eavesdropping. The dashed cyan contour marks the 11% Shor-Preskill limit. Everything above and to the right must be aborted. Notice the fundamental equifinality: multiple distinct combinations of noise and interception map to identical QBER values.</a:t>
-            </a:r>
-          </a:p>
-        </p:txBody>
-      </p:sp>
-      <p:sp>
-        <p:nvSpPr>
-          <p:cNvPr id="4" name="Slide Number Placeholder 3"/>
-          <p:cNvSpPr>
-            <a:spLocks noGrp="1"/>
-          </p:cNvSpPr>
-          <p:nvPr>
-            <p:ph type="sldNum" idx="5" sz="quarter"/>
+            <p:ph type="sldNum" sz="quarter" idx="5"/>
           </p:nvPr>
         </p:nvSpPr>
         <p:spPr/>
@@ -1310,7 +1104,7 @@
 </file>
 
 <file path=ppt/notesSlides/notesSlide9.xml><?xml version="1.0" encoding="utf-8"?>
-<p:notes xmlns:a="http://schemas.openxmlformats.org/drawingml/2006/main" xmlns:p="http://schemas.openxmlformats.org/presentationml/2006/main" xmlns:r="http://schemas.openxmlformats.org/officeDocument/2006/relationships">
+<p:notes xmlns:a="http://schemas.openxmlformats.org/drawingml/2006/main" xmlns:r="http://schemas.openxmlformats.org/officeDocument/2006/relationships" xmlns:p="http://schemas.openxmlformats.org/presentationml/2006/main">
   <p:cSld>
     <p:spTree>
       <p:nvGrpSpPr>
@@ -1330,43 +1124,43 @@
         <p:nvSpPr>
           <p:cNvPr id="2" name="Slide Image Placeholder 1"/>
           <p:cNvSpPr>
+            <a:spLocks noGrp="1" noRot="1" noChangeAspect="1"/>
+          </p:cNvSpPr>
+          <p:nvPr>
+            <p:ph type="sldImg" idx="2"/>
+          </p:nvPr>
+        </p:nvSpPr>
+        <p:spPr/>
+      </p:sp>
+      <p:sp>
+        <p:nvSpPr>
+          <p:cNvPr id="3" name="Notes Placeholder 2"/>
+          <p:cNvSpPr>
             <a:spLocks noGrp="1"/>
           </p:cNvSpPr>
           <p:nvPr>
-            <p:ph type="sldImg" idx="2"/>
+            <p:ph type="body" sz="quarter" idx="3"/>
           </p:nvPr>
         </p:nvSpPr>
         <p:spPr/>
-      </p:sp>
-      <p:sp>
-        <p:nvSpPr>
-          <p:cNvPr id="3" name="Notes Placeholder 2"/>
+        <p:txBody>
+          <a:bodyPr/>
+          <a:lstStyle/>
+          <a:p>
+            <a:r>
+              <a:t>Slide 9 reveals our answer to the central research question. When operating near the 11% threshold, small sample sizes of 50 bits suffer from high binomial variance, leading to 26% false alarms and 28% missed detections. By scaling the sacrificed sample size to K &gt;= 600 bits, Alice and Bob compress the error variance and eliminate both errors to under 1%.</a:t>
+            </a:r>
+          </a:p>
+        </p:txBody>
+      </p:sp>
+      <p:sp>
+        <p:nvSpPr>
+          <p:cNvPr id="4" name="Slide Number Placeholder 3"/>
           <p:cNvSpPr>
             <a:spLocks noGrp="1"/>
           </p:cNvSpPr>
           <p:nvPr>
-            <p:ph type="body" idx="3" sz="quarter"/>
-          </p:nvPr>
-        </p:nvSpPr>
-        <p:spPr/>
-        <p:txBody>
-          <a:bodyPr/>
-          <a:lstStyle/>
-          <a:p>
-            <a:r>
-              <a:t>Slide 9 reveals our answer to the central research question. When operating near the 11% threshold, small sample sizes of 50 bits suffer from high binomial variance, leading to 26% false alarms and 28% missed detections. By scaling the sacrificed sample size to K &gt;= 600 bits, Alice and Bob compress the error variance and eliminate both errors to under 1%.</a:t>
-            </a:r>
-          </a:p>
-        </p:txBody>
-      </p:sp>
-      <p:sp>
-        <p:nvSpPr>
-          <p:cNvPr id="4" name="Slide Number Placeholder 3"/>
-          <p:cNvSpPr>
-            <a:spLocks noGrp="1"/>
-          </p:cNvSpPr>
-          <p:nvPr>
-            <p:ph type="sldNum" idx="5" sz="quarter"/>
+            <p:ph type="sldNum" sz="quarter" idx="5"/>
           </p:nvPr>
         </p:nvSpPr>
         <p:spPr/>
@@ -1417,10 +1211,9 @@
           <a:lstStyle/>
           <a:p>
             <a:r>
-              <a:rPr lang="en-US" smtClean="0"/>
+              <a:rPr lang="en-US"/>
               <a:t>Click to edit Master title style</a:t>
             </a:r>
-            <a:endParaRPr lang="en-US"/>
           </a:p>
         </p:txBody>
       </p:sp>
@@ -1536,10 +1329,9 @@
           </a:lstStyle>
           <a:p>
             <a:r>
-              <a:rPr lang="en-US" smtClean="0"/>
+              <a:rPr lang="en-US"/>
               <a:t>Click to edit Master subtitle style</a:t>
             </a:r>
-            <a:endParaRPr lang="en-US"/>
           </a:p>
         </p:txBody>
       </p:sp>
@@ -1560,7 +1352,7 @@
           <a:p>
             <a:fld id="{5BCAD085-E8A6-8845-BD4E-CB4CCA059FC4}" type="datetimeFigureOut">
               <a:rPr lang="en-US" smtClean="0"/>
-              <a:t>1/27/13</a:t>
+              <a:t>10/22/2026</a:t>
             </a:fld>
             <a:endParaRPr lang="en-US"/>
           </a:p>
@@ -1654,10 +1446,9 @@
           <a:lstStyle/>
           <a:p>
             <a:r>
-              <a:rPr lang="en-US" smtClean="0"/>
+              <a:rPr lang="en-US"/>
               <a:t>Click to edit Master title style</a:t>
             </a:r>
-            <a:endParaRPr lang="en-US"/>
           </a:p>
         </p:txBody>
       </p:sp>
@@ -1678,38 +1469,37 @@
           <a:p>
             <a:pPr lvl="0"/>
             <a:r>
-              <a:rPr lang="en-US" smtClean="0"/>
+              <a:rPr lang="en-US"/>
               <a:t>Click to edit Master text styles</a:t>
             </a:r>
           </a:p>
           <a:p>
             <a:pPr lvl="1"/>
             <a:r>
-              <a:rPr lang="en-US" smtClean="0"/>
+              <a:rPr lang="en-US"/>
               <a:t>Second level</a:t>
             </a:r>
           </a:p>
           <a:p>
             <a:pPr lvl="2"/>
             <a:r>
-              <a:rPr lang="en-US" smtClean="0"/>
+              <a:rPr lang="en-US"/>
               <a:t>Third level</a:t>
             </a:r>
           </a:p>
           <a:p>
             <a:pPr lvl="3"/>
             <a:r>
-              <a:rPr lang="en-US" smtClean="0"/>
+              <a:rPr lang="en-US"/>
               <a:t>Fourth level</a:t>
             </a:r>
           </a:p>
           <a:p>
             <a:pPr lvl="4"/>
             <a:r>
-              <a:rPr lang="en-US" smtClean="0"/>
+              <a:rPr lang="en-US"/>
               <a:t>Fifth level</a:t>
             </a:r>
-            <a:endParaRPr lang="en-US"/>
           </a:p>
         </p:txBody>
       </p:sp>
@@ -1730,7 +1520,7 @@
           <a:p>
             <a:fld id="{5BCAD085-E8A6-8845-BD4E-CB4CCA059FC4}" type="datetimeFigureOut">
               <a:rPr lang="en-US" smtClean="0"/>
-              <a:t>1/27/13</a:t>
+              <a:t>10/22/2026</a:t>
             </a:fld>
             <a:endParaRPr lang="en-US"/>
           </a:p>
@@ -1829,10 +1619,9 @@
           <a:lstStyle/>
           <a:p>
             <a:r>
-              <a:rPr lang="en-US" smtClean="0"/>
+              <a:rPr lang="en-US"/>
               <a:t>Click to edit Master title style</a:t>
             </a:r>
-            <a:endParaRPr lang="en-US"/>
           </a:p>
         </p:txBody>
       </p:sp>
@@ -1858,38 +1647,37 @@
           <a:p>
             <a:pPr lvl="0"/>
             <a:r>
-              <a:rPr lang="en-US" smtClean="0"/>
+              <a:rPr lang="en-US"/>
               <a:t>Click to edit Master text styles</a:t>
             </a:r>
           </a:p>
           <a:p>
             <a:pPr lvl="1"/>
             <a:r>
-              <a:rPr lang="en-US" smtClean="0"/>
+              <a:rPr lang="en-US"/>
               <a:t>Second level</a:t>
             </a:r>
           </a:p>
           <a:p>
             <a:pPr lvl="2"/>
             <a:r>
-              <a:rPr lang="en-US" smtClean="0"/>
+              <a:rPr lang="en-US"/>
               <a:t>Third level</a:t>
             </a:r>
           </a:p>
           <a:p>
             <a:pPr lvl="3"/>
             <a:r>
-              <a:rPr lang="en-US" smtClean="0"/>
+              <a:rPr lang="en-US"/>
               <a:t>Fourth level</a:t>
             </a:r>
           </a:p>
           <a:p>
             <a:pPr lvl="4"/>
             <a:r>
-              <a:rPr lang="en-US" smtClean="0"/>
+              <a:rPr lang="en-US"/>
               <a:t>Fifth level</a:t>
             </a:r>
-            <a:endParaRPr lang="en-US"/>
           </a:p>
         </p:txBody>
       </p:sp>
@@ -1910,7 +1698,7 @@
           <a:p>
             <a:fld id="{5BCAD085-E8A6-8845-BD4E-CB4CCA059FC4}" type="datetimeFigureOut">
               <a:rPr lang="en-US" smtClean="0"/>
-              <a:t>1/27/13</a:t>
+              <a:t>10/22/2026</a:t>
             </a:fld>
             <a:endParaRPr lang="en-US"/>
           </a:p>
@@ -2004,10 +1792,9 @@
           <a:lstStyle/>
           <a:p>
             <a:r>
-              <a:rPr lang="en-US" smtClean="0"/>
+              <a:rPr lang="en-US"/>
               <a:t>Click to edit Master title style</a:t>
             </a:r>
-            <a:endParaRPr lang="en-US"/>
           </a:p>
         </p:txBody>
       </p:sp>
@@ -2028,38 +1815,37 @@
           <a:p>
             <a:pPr lvl="0"/>
             <a:r>
-              <a:rPr lang="en-US" smtClean="0"/>
+              <a:rPr lang="en-US"/>
               <a:t>Click to edit Master text styles</a:t>
             </a:r>
           </a:p>
           <a:p>
             <a:pPr lvl="1"/>
             <a:r>
-              <a:rPr lang="en-US" smtClean="0"/>
+              <a:rPr lang="en-US"/>
               <a:t>Second level</a:t>
             </a:r>
           </a:p>
           <a:p>
             <a:pPr lvl="2"/>
             <a:r>
-              <a:rPr lang="en-US" smtClean="0"/>
+              <a:rPr lang="en-US"/>
               <a:t>Third level</a:t>
             </a:r>
           </a:p>
           <a:p>
             <a:pPr lvl="3"/>
             <a:r>
-              <a:rPr lang="en-US" smtClean="0"/>
+              <a:rPr lang="en-US"/>
               <a:t>Fourth level</a:t>
             </a:r>
           </a:p>
           <a:p>
             <a:pPr lvl="4"/>
             <a:r>
-              <a:rPr lang="en-US" smtClean="0"/>
+              <a:rPr lang="en-US"/>
               <a:t>Fifth level</a:t>
             </a:r>
-            <a:endParaRPr lang="en-US"/>
           </a:p>
         </p:txBody>
       </p:sp>
@@ -2080,7 +1866,7 @@
           <a:p>
             <a:fld id="{5BCAD085-E8A6-8845-BD4E-CB4CCA059FC4}" type="datetimeFigureOut">
               <a:rPr lang="en-US" smtClean="0"/>
-              <a:t>1/27/13</a:t>
+              <a:t>10/22/2026</a:t>
             </a:fld>
             <a:endParaRPr lang="en-US"/>
           </a:p>
@@ -2183,10 +1969,9 @@
           </a:lstStyle>
           <a:p>
             <a:r>
-              <a:rPr lang="en-US" smtClean="0"/>
+              <a:rPr lang="en-US"/>
               <a:t>Click to edit Master title style</a:t>
             </a:r>
-            <a:endParaRPr lang="en-US"/>
           </a:p>
         </p:txBody>
       </p:sp>
@@ -2303,7 +2088,7 @@
           <a:p>
             <a:pPr lvl="0"/>
             <a:r>
-              <a:rPr lang="en-US" smtClean="0"/>
+              <a:rPr lang="en-US"/>
               <a:t>Click to edit Master text styles</a:t>
             </a:r>
           </a:p>
@@ -2326,7 +2111,7 @@
           <a:p>
             <a:fld id="{5BCAD085-E8A6-8845-BD4E-CB4CCA059FC4}" type="datetimeFigureOut">
               <a:rPr lang="en-US" smtClean="0"/>
-              <a:t>1/27/13</a:t>
+              <a:t>10/22/2026</a:t>
             </a:fld>
             <a:endParaRPr lang="en-US"/>
           </a:p>
@@ -2420,10 +2205,9 @@
           <a:lstStyle/>
           <a:p>
             <a:r>
-              <a:rPr lang="en-US" smtClean="0"/>
+              <a:rPr lang="en-US"/>
               <a:t>Click to edit Master title style</a:t>
             </a:r>
-            <a:endParaRPr lang="en-US"/>
           </a:p>
         </p:txBody>
       </p:sp>
@@ -2477,38 +2261,37 @@
           <a:p>
             <a:pPr lvl="0"/>
             <a:r>
-              <a:rPr lang="en-US" smtClean="0"/>
+              <a:rPr lang="en-US"/>
               <a:t>Click to edit Master text styles</a:t>
             </a:r>
           </a:p>
           <a:p>
             <a:pPr lvl="1"/>
             <a:r>
-              <a:rPr lang="en-US" smtClean="0"/>
+              <a:rPr lang="en-US"/>
               <a:t>Second level</a:t>
             </a:r>
           </a:p>
           <a:p>
             <a:pPr lvl="2"/>
             <a:r>
-              <a:rPr lang="en-US" smtClean="0"/>
+              <a:rPr lang="en-US"/>
               <a:t>Third level</a:t>
             </a:r>
           </a:p>
           <a:p>
             <a:pPr lvl="3"/>
             <a:r>
-              <a:rPr lang="en-US" smtClean="0"/>
+              <a:rPr lang="en-US"/>
               <a:t>Fourth level</a:t>
             </a:r>
           </a:p>
           <a:p>
             <a:pPr lvl="4"/>
             <a:r>
-              <a:rPr lang="en-US" smtClean="0"/>
+              <a:rPr lang="en-US"/>
               <a:t>Fifth level</a:t>
             </a:r>
-            <a:endParaRPr lang="en-US"/>
           </a:p>
         </p:txBody>
       </p:sp>
@@ -2562,38 +2345,37 @@
           <a:p>
             <a:pPr lvl="0"/>
             <a:r>
-              <a:rPr lang="en-US" smtClean="0"/>
+              <a:rPr lang="en-US"/>
               <a:t>Click to edit Master text styles</a:t>
             </a:r>
           </a:p>
           <a:p>
             <a:pPr lvl="1"/>
             <a:r>
-              <a:rPr lang="en-US" smtClean="0"/>
+              <a:rPr lang="en-US"/>
               <a:t>Second level</a:t>
             </a:r>
           </a:p>
           <a:p>
             <a:pPr lvl="2"/>
             <a:r>
-              <a:rPr lang="en-US" smtClean="0"/>
+              <a:rPr lang="en-US"/>
               <a:t>Third level</a:t>
             </a:r>
           </a:p>
           <a:p>
             <a:pPr lvl="3"/>
             <a:r>
-              <a:rPr lang="en-US" smtClean="0"/>
+              <a:rPr lang="en-US"/>
               <a:t>Fourth level</a:t>
             </a:r>
           </a:p>
           <a:p>
             <a:pPr lvl="4"/>
             <a:r>
-              <a:rPr lang="en-US" smtClean="0"/>
+              <a:rPr lang="en-US"/>
               <a:t>Fifth level</a:t>
             </a:r>
-            <a:endParaRPr lang="en-US"/>
           </a:p>
         </p:txBody>
       </p:sp>
@@ -2614,7 +2396,7 @@
           <a:p>
             <a:fld id="{5BCAD085-E8A6-8845-BD4E-CB4CCA059FC4}" type="datetimeFigureOut">
               <a:rPr lang="en-US" smtClean="0"/>
-              <a:t>1/27/13</a:t>
+              <a:t>10/22/2026</a:t>
             </a:fld>
             <a:endParaRPr lang="en-US"/>
           </a:p>
@@ -2712,10 +2494,9 @@
           </a:lstStyle>
           <a:p>
             <a:r>
-              <a:rPr lang="en-US" smtClean="0"/>
+              <a:rPr lang="en-US"/>
               <a:t>Click to edit Master title style</a:t>
             </a:r>
-            <a:endParaRPr lang="en-US"/>
           </a:p>
         </p:txBody>
       </p:sp>
@@ -2778,7 +2559,7 @@
           <a:p>
             <a:pPr lvl="0"/>
             <a:r>
-              <a:rPr lang="en-US" smtClean="0"/>
+              <a:rPr lang="en-US"/>
               <a:t>Click to edit Master text styles</a:t>
             </a:r>
           </a:p>
@@ -2834,38 +2615,37 @@
           <a:p>
             <a:pPr lvl="0"/>
             <a:r>
-              <a:rPr lang="en-US" smtClean="0"/>
+              <a:rPr lang="en-US"/>
               <a:t>Click to edit Master text styles</a:t>
             </a:r>
           </a:p>
           <a:p>
             <a:pPr lvl="1"/>
             <a:r>
-              <a:rPr lang="en-US" smtClean="0"/>
+              <a:rPr lang="en-US"/>
               <a:t>Second level</a:t>
             </a:r>
           </a:p>
           <a:p>
             <a:pPr lvl="2"/>
             <a:r>
-              <a:rPr lang="en-US" smtClean="0"/>
+              <a:rPr lang="en-US"/>
               <a:t>Third level</a:t>
             </a:r>
           </a:p>
           <a:p>
             <a:pPr lvl="3"/>
             <a:r>
-              <a:rPr lang="en-US" smtClean="0"/>
+              <a:rPr lang="en-US"/>
               <a:t>Fourth level</a:t>
             </a:r>
           </a:p>
           <a:p>
             <a:pPr lvl="4"/>
             <a:r>
-              <a:rPr lang="en-US" smtClean="0"/>
+              <a:rPr lang="en-US"/>
               <a:t>Fifth level</a:t>
             </a:r>
-            <a:endParaRPr lang="en-US"/>
           </a:p>
         </p:txBody>
       </p:sp>
@@ -2928,7 +2708,7 @@
           <a:p>
             <a:pPr lvl="0"/>
             <a:r>
-              <a:rPr lang="en-US" smtClean="0"/>
+              <a:rPr lang="en-US"/>
               <a:t>Click to edit Master text styles</a:t>
             </a:r>
           </a:p>
@@ -2984,38 +2764,37 @@
           <a:p>
             <a:pPr lvl="0"/>
             <a:r>
-              <a:rPr lang="en-US" smtClean="0"/>
+              <a:rPr lang="en-US"/>
               <a:t>Click to edit Master text styles</a:t>
             </a:r>
           </a:p>
           <a:p>
             <a:pPr lvl="1"/>
             <a:r>
-              <a:rPr lang="en-US" smtClean="0"/>
+              <a:rPr lang="en-US"/>
               <a:t>Second level</a:t>
             </a:r>
           </a:p>
           <a:p>
             <a:pPr lvl="2"/>
             <a:r>
-              <a:rPr lang="en-US" smtClean="0"/>
+              <a:rPr lang="en-US"/>
               <a:t>Third level</a:t>
             </a:r>
           </a:p>
           <a:p>
             <a:pPr lvl="3"/>
             <a:r>
-              <a:rPr lang="en-US" smtClean="0"/>
+              <a:rPr lang="en-US"/>
               <a:t>Fourth level</a:t>
             </a:r>
           </a:p>
           <a:p>
             <a:pPr lvl="4"/>
             <a:r>
-              <a:rPr lang="en-US" smtClean="0"/>
+              <a:rPr lang="en-US"/>
               <a:t>Fifth level</a:t>
             </a:r>
-            <a:endParaRPr lang="en-US"/>
           </a:p>
         </p:txBody>
       </p:sp>
@@ -3036,7 +2815,7 @@
           <a:p>
             <a:fld id="{5BCAD085-E8A6-8845-BD4E-CB4CCA059FC4}" type="datetimeFigureOut">
               <a:rPr lang="en-US" smtClean="0"/>
-              <a:t>1/27/13</a:t>
+              <a:t>10/22/2026</a:t>
             </a:fld>
             <a:endParaRPr lang="en-US"/>
           </a:p>
@@ -3130,10 +2909,9 @@
           <a:lstStyle/>
           <a:p>
             <a:r>
-              <a:rPr lang="en-US" smtClean="0"/>
+              <a:rPr lang="en-US"/>
               <a:t>Click to edit Master title style</a:t>
             </a:r>
-            <a:endParaRPr lang="en-US"/>
           </a:p>
         </p:txBody>
       </p:sp>
@@ -3154,7 +2932,7 @@
           <a:p>
             <a:fld id="{5BCAD085-E8A6-8845-BD4E-CB4CCA059FC4}" type="datetimeFigureOut">
               <a:rPr lang="en-US" smtClean="0"/>
-              <a:t>1/27/13</a:t>
+              <a:t>10/22/2026</a:t>
             </a:fld>
             <a:endParaRPr lang="en-US"/>
           </a:p>
@@ -3249,7 +3027,7 @@
           <a:p>
             <a:fld id="{5BCAD085-E8A6-8845-BD4E-CB4CCA059FC4}" type="datetimeFigureOut">
               <a:rPr lang="en-US" smtClean="0"/>
-              <a:t>1/27/13</a:t>
+              <a:t>10/22/2026</a:t>
             </a:fld>
             <a:endParaRPr lang="en-US"/>
           </a:p>
@@ -3352,10 +3130,9 @@
           </a:lstStyle>
           <a:p>
             <a:r>
-              <a:rPr lang="en-US" smtClean="0"/>
+              <a:rPr lang="en-US"/>
               <a:t>Click to edit Master title style</a:t>
             </a:r>
-            <a:endParaRPr lang="en-US"/>
           </a:p>
         </p:txBody>
       </p:sp>
@@ -3409,38 +3186,37 @@
           <a:p>
             <a:pPr lvl="0"/>
             <a:r>
-              <a:rPr lang="en-US" smtClean="0"/>
+              <a:rPr lang="en-US"/>
               <a:t>Click to edit Master text styles</a:t>
             </a:r>
           </a:p>
           <a:p>
             <a:pPr lvl="1"/>
             <a:r>
-              <a:rPr lang="en-US" smtClean="0"/>
+              <a:rPr lang="en-US"/>
               <a:t>Second level</a:t>
             </a:r>
           </a:p>
           <a:p>
             <a:pPr lvl="2"/>
             <a:r>
-              <a:rPr lang="en-US" smtClean="0"/>
+              <a:rPr lang="en-US"/>
               <a:t>Third level</a:t>
             </a:r>
           </a:p>
           <a:p>
             <a:pPr lvl="3"/>
             <a:r>
-              <a:rPr lang="en-US" smtClean="0"/>
+              <a:rPr lang="en-US"/>
               <a:t>Fourth level</a:t>
             </a:r>
           </a:p>
           <a:p>
             <a:pPr lvl="4"/>
             <a:r>
-              <a:rPr lang="en-US" smtClean="0"/>
+              <a:rPr lang="en-US"/>
               <a:t>Fifth level</a:t>
             </a:r>
-            <a:endParaRPr lang="en-US"/>
           </a:p>
         </p:txBody>
       </p:sp>
@@ -3503,7 +3279,7 @@
           <a:p>
             <a:pPr lvl="0"/>
             <a:r>
-              <a:rPr lang="en-US" smtClean="0"/>
+              <a:rPr lang="en-US"/>
               <a:t>Click to edit Master text styles</a:t>
             </a:r>
           </a:p>
@@ -3526,7 +3302,7 @@
           <a:p>
             <a:fld id="{5BCAD085-E8A6-8845-BD4E-CB4CCA059FC4}" type="datetimeFigureOut">
               <a:rPr lang="en-US" smtClean="0"/>
-              <a:t>1/27/13</a:t>
+              <a:t>10/22/2026</a:t>
             </a:fld>
             <a:endParaRPr lang="en-US"/>
           </a:p>
@@ -3629,10 +3405,9 @@
           </a:lstStyle>
           <a:p>
             <a:r>
-              <a:rPr lang="en-US" smtClean="0"/>
+              <a:rPr lang="en-US"/>
               <a:t>Click to edit Master title style</a:t>
             </a:r>
-            <a:endParaRPr lang="en-US"/>
           </a:p>
         </p:txBody>
       </p:sp>
@@ -3756,7 +3531,7 @@
           <a:p>
             <a:pPr lvl="0"/>
             <a:r>
-              <a:rPr lang="en-US" smtClean="0"/>
+              <a:rPr lang="en-US"/>
               <a:t>Click to edit Master text styles</a:t>
             </a:r>
           </a:p>
@@ -3779,7 +3554,7 @@
           <a:p>
             <a:fld id="{5BCAD085-E8A6-8845-BD4E-CB4CCA059FC4}" type="datetimeFigureOut">
               <a:rPr lang="en-US" smtClean="0"/>
-              <a:t>1/27/13</a:t>
+              <a:t>10/22/2026</a:t>
             </a:fld>
             <a:endParaRPr lang="en-US"/>
           </a:p>
@@ -3888,10 +3663,9 @@
           <a:lstStyle/>
           <a:p>
             <a:r>
-              <a:rPr lang="en-US" smtClean="0"/>
+              <a:rPr lang="en-US"/>
               <a:t>Click to edit Master title style</a:t>
             </a:r>
-            <a:endParaRPr lang="en-US"/>
           </a:p>
         </p:txBody>
       </p:sp>
@@ -3922,38 +3696,37 @@
           <a:p>
             <a:pPr lvl="0"/>
             <a:r>
-              <a:rPr lang="en-US" smtClean="0"/>
+              <a:rPr lang="en-US"/>
               <a:t>Click to edit Master text styles</a:t>
             </a:r>
           </a:p>
           <a:p>
             <a:pPr lvl="1"/>
             <a:r>
-              <a:rPr lang="en-US" smtClean="0"/>
+              <a:rPr lang="en-US"/>
               <a:t>Second level</a:t>
             </a:r>
           </a:p>
           <a:p>
             <a:pPr lvl="2"/>
             <a:r>
-              <a:rPr lang="en-US" smtClean="0"/>
+              <a:rPr lang="en-US"/>
               <a:t>Third level</a:t>
             </a:r>
           </a:p>
           <a:p>
             <a:pPr lvl="3"/>
             <a:r>
-              <a:rPr lang="en-US" smtClean="0"/>
+              <a:rPr lang="en-US"/>
               <a:t>Fourth level</a:t>
             </a:r>
           </a:p>
           <a:p>
             <a:pPr lvl="4"/>
             <a:r>
-              <a:rPr lang="en-US" smtClean="0"/>
+              <a:rPr lang="en-US"/>
               <a:t>Fifth level</a:t>
             </a:r>
-            <a:endParaRPr lang="en-US"/>
           </a:p>
         </p:txBody>
       </p:sp>
@@ -3992,7 +3765,7 @@
           <a:p>
             <a:fld id="{5BCAD085-E8A6-8845-BD4E-CB4CCA059FC4}" type="datetimeFigureOut">
               <a:rPr lang="en-US" smtClean="0"/>
-              <a:t>1/27/13</a:t>
+              <a:t>10/22/2026</a:t>
             </a:fld>
             <a:endParaRPr lang="en-US"/>
           </a:p>
@@ -4351,7 +4124,7 @@
 </file>
 
 <file path=ppt/slides/slide1.xml><?xml version="1.0" encoding="utf-8"?>
-<p:sld xmlns:a="http://schemas.openxmlformats.org/drawingml/2006/main" xmlns:p="http://schemas.openxmlformats.org/presentationml/2006/main" xmlns:r="http://schemas.openxmlformats.org/officeDocument/2006/relationships">
+<p:sld xmlns:a="http://schemas.openxmlformats.org/drawingml/2006/main" xmlns:r="http://schemas.openxmlformats.org/officeDocument/2006/relationships" xmlns:p="http://schemas.openxmlformats.org/presentationml/2006/main">
   <p:cSld>
     <p:spTree>
       <p:nvGrpSpPr>
@@ -4359,7 +4132,14 @@
         <p:cNvGrpSpPr/>
         <p:nvPr/>
       </p:nvGrpSpPr>
-      <p:grpSpPr/>
+      <p:grpSpPr>
+        <a:xfrm>
+          <a:off x="0" y="0"/>
+          <a:ext cx="0" cy="0"/>
+          <a:chOff x="0" y="0"/>
+          <a:chExt cx="0" cy="0"/>
+        </a:xfrm>
+      </p:grpSpPr>
       <p:sp>
         <p:nvSpPr>
           <p:cNvPr id="2" name="Rectangle 1"/>
@@ -4400,6 +4180,7 @@
           <a:lstStyle/>
           <a:p>
             <a:pPr algn="ctr"/>
+            <a:endParaRPr/>
           </a:p>
         </p:txBody>
       </p:sp>
@@ -4481,7 +4262,7 @@
 </file>
 
 <file path=ppt/slides/slide10.xml><?xml version="1.0" encoding="utf-8"?>
-<p:sld xmlns:a="http://schemas.openxmlformats.org/drawingml/2006/main" xmlns:p="http://schemas.openxmlformats.org/presentationml/2006/main" xmlns:r="http://schemas.openxmlformats.org/officeDocument/2006/relationships">
+<p:sld xmlns:a="http://schemas.openxmlformats.org/drawingml/2006/main" xmlns:r="http://schemas.openxmlformats.org/officeDocument/2006/relationships" xmlns:p="http://schemas.openxmlformats.org/presentationml/2006/main">
   <p:cSld>
     <p:spTree>
       <p:nvGrpSpPr>
@@ -4489,7 +4270,14 @@
         <p:cNvGrpSpPr/>
         <p:nvPr/>
       </p:nvGrpSpPr>
-      <p:grpSpPr/>
+      <p:grpSpPr>
+        <a:xfrm>
+          <a:off x="0" y="0"/>
+          <a:ext cx="0" cy="0"/>
+          <a:chOff x="0" y="0"/>
+          <a:chExt cx="0" cy="0"/>
+        </a:xfrm>
+      </p:grpSpPr>
       <p:sp>
         <p:nvSpPr>
           <p:cNvPr id="2" name="TextBox 1"/>
@@ -4579,6 +4367,7 @@
           <a:lstStyle/>
           <a:p>
             <a:pPr algn="ctr"/>
+            <a:endParaRPr/>
           </a:p>
         </p:txBody>
       </p:sp>
@@ -4682,6 +4471,7 @@
           <a:lstStyle/>
           <a:p>
             <a:pPr algn="ctr"/>
+            <a:endParaRPr/>
           </a:p>
         </p:txBody>
       </p:sp>
@@ -4781,6 +4571,7 @@
           <a:lstStyle/>
           <a:p>
             <a:pPr algn="ctr"/>
+            <a:endParaRPr/>
           </a:p>
         </p:txBody>
       </p:sp>
@@ -4884,6 +4675,7 @@
           <a:lstStyle/>
           <a:p>
             <a:pPr algn="ctr"/>
+            <a:endParaRPr/>
           </a:p>
         </p:txBody>
       </p:sp>
@@ -4946,7 +4738,7 @@
 </file>
 
 <file path=ppt/slides/slide11.xml><?xml version="1.0" encoding="utf-8"?>
-<p:sld xmlns:a="http://schemas.openxmlformats.org/drawingml/2006/main" xmlns:p="http://schemas.openxmlformats.org/presentationml/2006/main" xmlns:r="http://schemas.openxmlformats.org/officeDocument/2006/relationships">
+<p:sld xmlns:a="http://schemas.openxmlformats.org/drawingml/2006/main" xmlns:r="http://schemas.openxmlformats.org/officeDocument/2006/relationships" xmlns:p="http://schemas.openxmlformats.org/presentationml/2006/main">
   <p:cSld>
     <p:spTree>
       <p:nvGrpSpPr>
@@ -4954,7 +4746,14 @@
         <p:cNvGrpSpPr/>
         <p:nvPr/>
       </p:nvGrpSpPr>
-      <p:grpSpPr/>
+      <p:grpSpPr>
+        <a:xfrm>
+          <a:off x="0" y="0"/>
+          <a:ext cx="0" cy="0"/>
+          <a:chOff x="0" y="0"/>
+          <a:chExt cx="0" cy="0"/>
+        </a:xfrm>
+      </p:grpSpPr>
       <p:sp>
         <p:nvSpPr>
           <p:cNvPr id="2" name="TextBox 1"/>
@@ -5021,9 +4820,27 @@
                 <a:tableStyleId>{5C22544A-7EE6-4342-B048-85BDC9FD1C3A}</a:tableStyleId>
               </a:tblPr>
               <a:tblGrid>
-                <a:gridCol w="2926080"/>
-                <a:gridCol w="3840480"/>
-                <a:gridCol w="3931920"/>
+                <a:gridCol w="2926080">
+                  <a:extLst>
+                    <a:ext uri="{9D8B030D-6E8A-4147-A177-3AD203B41FA5}">
+                      <a16:colId xmlns:a16="http://schemas.microsoft.com/office/drawing/2014/main" val="20000"/>
+                    </a:ext>
+                  </a:extLst>
+                </a:gridCol>
+                <a:gridCol w="3840480">
+                  <a:extLst>
+                    <a:ext uri="{9D8B030D-6E8A-4147-A177-3AD203B41FA5}">
+                      <a16:colId xmlns:a16="http://schemas.microsoft.com/office/drawing/2014/main" val="20001"/>
+                    </a:ext>
+                  </a:extLst>
+                </a:gridCol>
+                <a:gridCol w="3931920">
+                  <a:extLst>
+                    <a:ext uri="{9D8B030D-6E8A-4147-A177-3AD203B41FA5}">
+                      <a16:colId xmlns:a16="http://schemas.microsoft.com/office/drawing/2014/main" val="20002"/>
+                    </a:ext>
+                  </a:extLst>
+                </a:gridCol>
               </a:tblGrid>
               <a:tr h="762000">
                 <a:tc>
@@ -5032,7 +4849,7 @@
                     <a:lstStyle/>
                     <a:p>
                       <a:pPr>
-                        <a:defRPr b="1" sz="1400">
+                        <a:defRPr sz="1400" b="1">
                           <a:solidFill>
                             <a:srgbClr val="FFFFFF"/>
                           </a:solidFill>
@@ -5055,7 +4872,7 @@
                     <a:lstStyle/>
                     <a:p>
                       <a:pPr>
-                        <a:defRPr b="1" sz="1400">
+                        <a:defRPr sz="1400" b="1">
                           <a:solidFill>
                             <a:srgbClr val="FFFFFF"/>
                           </a:solidFill>
@@ -5078,7 +4895,7 @@
                     <a:lstStyle/>
                     <a:p>
                       <a:pPr>
-                        <a:defRPr b="1" sz="1400">
+                        <a:defRPr sz="1400" b="1">
                           <a:solidFill>
                             <a:srgbClr val="FFFFFF"/>
                           </a:solidFill>
@@ -5095,6 +4912,11 @@
                     </a:solidFill>
                   </a:tcPr>
                 </a:tc>
+                <a:extLst>
+                  <a:ext uri="{0D108BD9-81ED-4DB2-BD59-A6C34878D82A}">
+                    <a16:rowId xmlns:a16="http://schemas.microsoft.com/office/drawing/2014/main" val="10000"/>
+                  </a:ext>
+                </a:extLst>
               </a:tr>
               <a:tr h="762000">
                 <a:tc>
@@ -5166,6 +4988,11 @@
                     </a:solidFill>
                   </a:tcPr>
                 </a:tc>
+                <a:extLst>
+                  <a:ext uri="{0D108BD9-81ED-4DB2-BD59-A6C34878D82A}">
+                    <a16:rowId xmlns:a16="http://schemas.microsoft.com/office/drawing/2014/main" val="10001"/>
+                  </a:ext>
+                </a:extLst>
               </a:tr>
               <a:tr h="762000">
                 <a:tc>
@@ -5237,6 +5064,11 @@
                     </a:solidFill>
                   </a:tcPr>
                 </a:tc>
+                <a:extLst>
+                  <a:ext uri="{0D108BD9-81ED-4DB2-BD59-A6C34878D82A}">
+                    <a16:rowId xmlns:a16="http://schemas.microsoft.com/office/drawing/2014/main" val="10002"/>
+                  </a:ext>
+                </a:extLst>
               </a:tr>
               <a:tr h="762000">
                 <a:tc>
@@ -5308,6 +5140,11 @@
                     </a:solidFill>
                   </a:tcPr>
                 </a:tc>
+                <a:extLst>
+                  <a:ext uri="{0D108BD9-81ED-4DB2-BD59-A6C34878D82A}">
+                    <a16:rowId xmlns:a16="http://schemas.microsoft.com/office/drawing/2014/main" val="10003"/>
+                  </a:ext>
+                </a:extLst>
               </a:tr>
               <a:tr h="762000">
                 <a:tc>
@@ -5379,6 +5216,11 @@
                     </a:solidFill>
                   </a:tcPr>
                 </a:tc>
+                <a:extLst>
+                  <a:ext uri="{0D108BD9-81ED-4DB2-BD59-A6C34878D82A}">
+                    <a16:rowId xmlns:a16="http://schemas.microsoft.com/office/drawing/2014/main" val="10004"/>
+                  </a:ext>
+                </a:extLst>
               </a:tr>
               <a:tr h="762000">
                 <a:tc>
@@ -5450,6 +5292,11 @@
                     </a:solidFill>
                   </a:tcPr>
                 </a:tc>
+                <a:extLst>
+                  <a:ext uri="{0D108BD9-81ED-4DB2-BD59-A6C34878D82A}">
+                    <a16:rowId xmlns:a16="http://schemas.microsoft.com/office/drawing/2014/main" val="10005"/>
+                  </a:ext>
+                </a:extLst>
               </a:tr>
             </a:tbl>
           </a:graphicData>
@@ -5464,7 +5311,7 @@
 </file>
 
 <file path=ppt/slides/slide12.xml><?xml version="1.0" encoding="utf-8"?>
-<p:sld xmlns:a="http://schemas.openxmlformats.org/drawingml/2006/main" xmlns:p="http://schemas.openxmlformats.org/presentationml/2006/main" xmlns:r="http://schemas.openxmlformats.org/officeDocument/2006/relationships">
+<p:sld xmlns:a="http://schemas.openxmlformats.org/drawingml/2006/main" xmlns:r="http://schemas.openxmlformats.org/officeDocument/2006/relationships" xmlns:p="http://schemas.openxmlformats.org/presentationml/2006/main">
   <p:cSld>
     <p:spTree>
       <p:nvGrpSpPr>
@@ -5472,7 +5319,14 @@
         <p:cNvGrpSpPr/>
         <p:nvPr/>
       </p:nvGrpSpPr>
-      <p:grpSpPr/>
+      <p:grpSpPr>
+        <a:xfrm>
+          <a:off x="0" y="0"/>
+          <a:ext cx="0" cy="0"/>
+          <a:chOff x="0" y="0"/>
+          <a:chExt cx="0" cy="0"/>
+        </a:xfrm>
+      </p:grpSpPr>
       <p:sp>
         <p:nvSpPr>
           <p:cNvPr id="2" name="TextBox 1"/>
@@ -5562,6 +5416,7 @@
           <a:lstStyle/>
           <a:p>
             <a:pPr algn="ctr"/>
+            <a:endParaRPr/>
           </a:p>
         </p:txBody>
       </p:sp>
@@ -5687,6 +5542,7 @@
           <a:lstStyle/>
           <a:p>
             <a:pPr algn="ctr"/>
+            <a:endParaRPr/>
           </a:p>
         </p:txBody>
       </p:sp>
@@ -5794,7 +5650,7 @@
 </file>
 
 <file path=ppt/slides/slide13.xml><?xml version="1.0" encoding="utf-8"?>
-<p:sld xmlns:a="http://schemas.openxmlformats.org/drawingml/2006/main" xmlns:p="http://schemas.openxmlformats.org/presentationml/2006/main" xmlns:r="http://schemas.openxmlformats.org/officeDocument/2006/relationships">
+<p:sld xmlns:a="http://schemas.openxmlformats.org/drawingml/2006/main" xmlns:r="http://schemas.openxmlformats.org/officeDocument/2006/relationships" xmlns:p="http://schemas.openxmlformats.org/presentationml/2006/main">
   <p:cSld>
     <p:spTree>
       <p:nvGrpSpPr>
@@ -5802,7 +5658,14 @@
         <p:cNvGrpSpPr/>
         <p:nvPr/>
       </p:nvGrpSpPr>
-      <p:grpSpPr/>
+      <p:grpSpPr>
+        <a:xfrm>
+          <a:off x="0" y="0"/>
+          <a:ext cx="0" cy="0"/>
+          <a:chOff x="0" y="0"/>
+          <a:chExt cx="0" cy="0"/>
+        </a:xfrm>
+      </p:grpSpPr>
       <p:sp>
         <p:nvSpPr>
           <p:cNvPr id="2" name="Rectangle 1"/>
@@ -5843,6 +5706,7 @@
           <a:lstStyle/>
           <a:p>
             <a:pPr algn="ctr"/>
+            <a:endParaRPr/>
           </a:p>
         </p:txBody>
       </p:sp>
@@ -5855,7 +5719,7 @@
         <p:spPr>
           <a:xfrm>
             <a:off x="1097280" y="1371600"/>
-            <a:ext cx="10058400" cy="4389120"/>
+            <a:ext cx="10058400" cy="3380413"/>
           </a:xfrm>
           <a:prstGeom prst="rect">
             <a:avLst/>
@@ -5876,6 +5740,7 @@
               </a:defRPr>
             </a:pPr>
             <a:r>
+              <a:rPr dirty="0"/>
               <a:t>Conclusion &amp; Submission</a:t>
             </a:r>
           </a:p>
@@ -5891,35 +5756,92 @@
               </a:defRPr>
             </a:pPr>
             <a:r>
-              <a:t>EveWatch demonstrates that while hardware noise and eavesdropping conflate at the raw QBER level, statistical sample scaling (K &gt;= 600) and link baseline calibration enable provable, reliable quantum security.</a:t>
-            </a:r>
-          </a:p>
-          <a:p>
-            <a:br/>
-            <a:pPr>
-              <a:spcBef>
-                <a:spcPts val="1600"/>
-              </a:spcBef>
-              <a:defRPr sz="1600">
-                <a:solidFill>
-                  <a:srgbClr val="94A3B8"/>
-                </a:solidFill>
-              </a:defRPr>
-            </a:pPr>
-            <a:r>
+              <a:rPr dirty="0" err="1"/>
+              <a:t>EveWatch</a:t>
+            </a:r>
+            <a:r>
+              <a:rPr dirty="0"/>
+              <a:t> demonstrates that while hardware noise and eavesdropping conflate at the raw QBER level, statistical sample scaling (K &gt;= 600) and link baseline calibration enable provable, reliable quantum security.</a:t>
+            </a:r>
+          </a:p>
+          <a:p>
+            <a:br>
+              <a:rPr dirty="0"/>
+            </a:br>
+            <a:r>
+              <a:rPr dirty="0">
+                <a:solidFill>
+                  <a:schemeClr val="bg1"/>
+                </a:solidFill>
+              </a:rPr>
               <a:t>📦 Open-Source GitHub Repository:</a:t>
             </a:r>
-            <a:br/>
-            <a:r>
+            <a:br>
+              <a:rPr dirty="0">
+                <a:solidFill>
+                  <a:schemeClr val="bg1"/>
+                </a:solidFill>
+              </a:rPr>
+            </a:br>
+            <a:r>
+              <a:rPr dirty="0">
+                <a:solidFill>
+                  <a:schemeClr val="bg1"/>
+                </a:solidFill>
+              </a:rPr>
               <a:t>https://github.com/Ayush-web28/EveWatch</a:t>
             </a:r>
-            <a:br/>
-            <a:br/>
-            <a:r>
-              <a:t>Team: Ayush Trivedi | Qiskit Fall Fest 2026 @ MPSTME, NMIMS Mumbai</a:t>
-            </a:r>
-            <a:br/>
-            <a:r>
+            <a:br>
+              <a:rPr dirty="0">
+                <a:solidFill>
+                  <a:schemeClr val="bg1"/>
+                </a:solidFill>
+              </a:rPr>
+            </a:br>
+            <a:br>
+              <a:rPr dirty="0">
+                <a:solidFill>
+                  <a:schemeClr val="bg1"/>
+                </a:solidFill>
+              </a:rPr>
+            </a:br>
+            <a:r>
+              <a:rPr dirty="0">
+                <a:solidFill>
+                  <a:schemeClr val="bg1"/>
+                </a:solidFill>
+              </a:rPr>
+              <a:t>Team: Ayush Trivedi | </a:t>
+            </a:r>
+            <a:r>
+              <a:rPr dirty="0" err="1">
+                <a:solidFill>
+                  <a:schemeClr val="bg1"/>
+                </a:solidFill>
+              </a:rPr>
+              <a:t>Qiskit</a:t>
+            </a:r>
+            <a:r>
+              <a:rPr dirty="0">
+                <a:solidFill>
+                  <a:schemeClr val="bg1"/>
+                </a:solidFill>
+              </a:rPr>
+              <a:t> Fall Fest 2026 @ MPSTME, NMIMS Mumbai</a:t>
+            </a:r>
+            <a:br>
+              <a:rPr dirty="0">
+                <a:solidFill>
+                  <a:schemeClr val="bg1"/>
+                </a:solidFill>
+              </a:rPr>
+            </a:br>
+            <a:r>
+              <a:rPr dirty="0">
+                <a:solidFill>
+                  <a:schemeClr val="bg1"/>
+                </a:solidFill>
+              </a:rPr>
               <a:t>Thank you to IBM Quantum and MPSTME mentors!</a:t>
             </a:r>
           </a:p>
@@ -5934,7 +5856,7 @@
 </file>
 
 <file path=ppt/slides/slide2.xml><?xml version="1.0" encoding="utf-8"?>
-<p:sld xmlns:a="http://schemas.openxmlformats.org/drawingml/2006/main" xmlns:p="http://schemas.openxmlformats.org/presentationml/2006/main" xmlns:r="http://schemas.openxmlformats.org/officeDocument/2006/relationships">
+<p:sld xmlns:a="http://schemas.openxmlformats.org/drawingml/2006/main" xmlns:r="http://schemas.openxmlformats.org/officeDocument/2006/relationships" xmlns:p="http://schemas.openxmlformats.org/presentationml/2006/main">
   <p:cSld>
     <p:spTree>
       <p:nvGrpSpPr>
@@ -5942,7 +5864,14 @@
         <p:cNvGrpSpPr/>
         <p:nvPr/>
       </p:nvGrpSpPr>
-      <p:grpSpPr/>
+      <p:grpSpPr>
+        <a:xfrm>
+          <a:off x="0" y="0"/>
+          <a:ext cx="0" cy="0"/>
+          <a:chOff x="0" y="0"/>
+          <a:chExt cx="0" cy="0"/>
+        </a:xfrm>
+      </p:grpSpPr>
       <p:sp>
         <p:nvSpPr>
           <p:cNvPr id="2" name="TextBox 1"/>
@@ -6032,6 +5961,7 @@
           <a:lstStyle/>
           <a:p>
             <a:pPr algn="ctr"/>
+            <a:endParaRPr/>
           </a:p>
         </p:txBody>
       </p:sp>
@@ -6157,6 +6087,7 @@
           <a:lstStyle/>
           <a:p>
             <a:pPr algn="ctr"/>
+            <a:endParaRPr/>
           </a:p>
         </p:txBody>
       </p:sp>
@@ -6264,7 +6195,7 @@
 </file>
 
 <file path=ppt/slides/slide3.xml><?xml version="1.0" encoding="utf-8"?>
-<p:sld xmlns:a="http://schemas.openxmlformats.org/drawingml/2006/main" xmlns:p="http://schemas.openxmlformats.org/presentationml/2006/main" xmlns:r="http://schemas.openxmlformats.org/officeDocument/2006/relationships">
+<p:sld xmlns:a="http://schemas.openxmlformats.org/drawingml/2006/main" xmlns:r="http://schemas.openxmlformats.org/officeDocument/2006/relationships" xmlns:p="http://schemas.openxmlformats.org/presentationml/2006/main">
   <p:cSld>
     <p:spTree>
       <p:nvGrpSpPr>
@@ -6272,7 +6203,14 @@
         <p:cNvGrpSpPr/>
         <p:nvPr/>
       </p:nvGrpSpPr>
-      <p:grpSpPr/>
+      <p:grpSpPr>
+        <a:xfrm>
+          <a:off x="0" y="0"/>
+          <a:ext cx="0" cy="0"/>
+          <a:chOff x="0" y="0"/>
+          <a:chExt cx="0" cy="0"/>
+        </a:xfrm>
+      </p:grpSpPr>
       <p:sp>
         <p:nvSpPr>
           <p:cNvPr id="2" name="TextBox 1"/>
@@ -6362,6 +6300,7 @@
           <a:lstStyle/>
           <a:p>
             <a:pPr algn="ctr"/>
+            <a:endParaRPr/>
           </a:p>
         </p:txBody>
       </p:sp>
@@ -6457,6 +6396,7 @@
           <a:lstStyle/>
           <a:p>
             <a:pPr algn="ctr"/>
+            <a:endParaRPr/>
           </a:p>
         </p:txBody>
       </p:sp>
@@ -6597,6 +6537,7 @@
           <a:lstStyle/>
           <a:p>
             <a:pPr algn="ctr"/>
+            <a:endParaRPr/>
           </a:p>
         </p:txBody>
       </p:sp>
@@ -6704,7 +6645,7 @@
 </file>
 
 <file path=ppt/slides/slide4.xml><?xml version="1.0" encoding="utf-8"?>
-<p:sld xmlns:a="http://schemas.openxmlformats.org/drawingml/2006/main" xmlns:p="http://schemas.openxmlformats.org/presentationml/2006/main" xmlns:r="http://schemas.openxmlformats.org/officeDocument/2006/relationships">
+<p:sld xmlns:a="http://schemas.openxmlformats.org/drawingml/2006/main" xmlns:r="http://schemas.openxmlformats.org/officeDocument/2006/relationships" xmlns:p="http://schemas.openxmlformats.org/presentationml/2006/main">
   <p:cSld>
     <p:spTree>
       <p:nvGrpSpPr>
@@ -6712,7 +6653,14 @@
         <p:cNvGrpSpPr/>
         <p:nvPr/>
       </p:nvGrpSpPr>
-      <p:grpSpPr/>
+      <p:grpSpPr>
+        <a:xfrm>
+          <a:off x="0" y="0"/>
+          <a:ext cx="0" cy="0"/>
+          <a:chOff x="0" y="0"/>
+          <a:chExt cx="0" cy="0"/>
+        </a:xfrm>
+      </p:grpSpPr>
       <p:sp>
         <p:nvSpPr>
           <p:cNvPr id="2" name="TextBox 1"/>
@@ -6802,6 +6750,7 @@
           <a:lstStyle/>
           <a:p>
             <a:pPr algn="ctr"/>
+            <a:endParaRPr/>
           </a:p>
         </p:txBody>
       </p:sp>
@@ -6897,6 +6846,7 @@
           <a:lstStyle/>
           <a:p>
             <a:pPr algn="ctr"/>
+            <a:endParaRPr/>
           </a:p>
         </p:txBody>
       </p:sp>
@@ -6992,6 +6942,7 @@
           <a:lstStyle/>
           <a:p>
             <a:pPr algn="ctr"/>
+            <a:endParaRPr/>
           </a:p>
         </p:txBody>
       </p:sp>
@@ -7087,6 +7038,7 @@
           <a:lstStyle/>
           <a:p>
             <a:pPr algn="ctr"/>
+            <a:endParaRPr/>
           </a:p>
         </p:txBody>
       </p:sp>
@@ -7149,7 +7101,7 @@
 </file>
 
 <file path=ppt/slides/slide5.xml><?xml version="1.0" encoding="utf-8"?>
-<p:sld xmlns:a="http://schemas.openxmlformats.org/drawingml/2006/main" xmlns:p="http://schemas.openxmlformats.org/presentationml/2006/main" xmlns:r="http://schemas.openxmlformats.org/officeDocument/2006/relationships">
+<p:sld xmlns:a="http://schemas.openxmlformats.org/drawingml/2006/main" xmlns:r="http://schemas.openxmlformats.org/officeDocument/2006/relationships" xmlns:p="http://schemas.openxmlformats.org/presentationml/2006/main">
   <p:cSld>
     <p:spTree>
       <p:nvGrpSpPr>
@@ -7157,7 +7109,14 @@
         <p:cNvGrpSpPr/>
         <p:nvPr/>
       </p:nvGrpSpPr>
-      <p:grpSpPr/>
+      <p:grpSpPr>
+        <a:xfrm>
+          <a:off x="0" y="0"/>
+          <a:ext cx="0" cy="0"/>
+          <a:chOff x="0" y="0"/>
+          <a:chExt cx="0" cy="0"/>
+        </a:xfrm>
+      </p:grpSpPr>
       <p:sp>
         <p:nvSpPr>
           <p:cNvPr id="2" name="TextBox 1"/>
@@ -7247,6 +7206,7 @@
           <a:lstStyle/>
           <a:p>
             <a:pPr algn="ctr"/>
+            <a:endParaRPr/>
           </a:p>
         </p:txBody>
       </p:sp>
@@ -7354,6 +7314,7 @@
           <a:lstStyle/>
           <a:p>
             <a:pPr algn="ctr"/>
+            <a:endParaRPr/>
           </a:p>
         </p:txBody>
       </p:sp>
@@ -7461,6 +7422,7 @@
           <a:lstStyle/>
           <a:p>
             <a:pPr algn="ctr"/>
+            <a:endParaRPr/>
           </a:p>
         </p:txBody>
       </p:sp>
@@ -7568,6 +7530,7 @@
           <a:lstStyle/>
           <a:p>
             <a:pPr algn="ctr"/>
+            <a:endParaRPr/>
           </a:p>
         </p:txBody>
       </p:sp>
@@ -7642,7 +7605,7 @@
 </file>
 
 <file path=ppt/slides/slide6.xml><?xml version="1.0" encoding="utf-8"?>
-<p:sld xmlns:a="http://schemas.openxmlformats.org/drawingml/2006/main" xmlns:p="http://schemas.openxmlformats.org/presentationml/2006/main" xmlns:r="http://schemas.openxmlformats.org/officeDocument/2006/relationships">
+<p:sld xmlns:a="http://schemas.openxmlformats.org/drawingml/2006/main" xmlns:r="http://schemas.openxmlformats.org/officeDocument/2006/relationships" xmlns:p="http://schemas.openxmlformats.org/presentationml/2006/main">
   <p:cSld>
     <p:spTree>
       <p:nvGrpSpPr>
@@ -7650,7 +7613,14 @@
         <p:cNvGrpSpPr/>
         <p:nvPr/>
       </p:nvGrpSpPr>
-      <p:grpSpPr/>
+      <p:grpSpPr>
+        <a:xfrm>
+          <a:off x="0" y="0"/>
+          <a:ext cx="0" cy="0"/>
+          <a:chOff x="0" y="0"/>
+          <a:chExt cx="0" cy="0"/>
+        </a:xfrm>
+      </p:grpSpPr>
       <p:sp>
         <p:nvSpPr>
           <p:cNvPr id="2" name="TextBox 1"/>
@@ -7740,6 +7710,7 @@
           <a:lstStyle/>
           <a:p>
             <a:pPr algn="ctr"/>
+            <a:endParaRPr/>
           </a:p>
         </p:txBody>
       </p:sp>
@@ -7880,6 +7851,7 @@
           <a:lstStyle/>
           <a:p>
             <a:pPr algn="ctr"/>
+            <a:endParaRPr/>
           </a:p>
         </p:txBody>
       </p:sp>
@@ -8002,7 +7974,7 @@
 </file>
 
 <file path=ppt/slides/slide7.xml><?xml version="1.0" encoding="utf-8"?>
-<p:sld xmlns:a="http://schemas.openxmlformats.org/drawingml/2006/main" xmlns:p="http://schemas.openxmlformats.org/presentationml/2006/main" xmlns:r="http://schemas.openxmlformats.org/officeDocument/2006/relationships">
+<p:sld xmlns:a="http://schemas.openxmlformats.org/drawingml/2006/main" xmlns:r="http://schemas.openxmlformats.org/officeDocument/2006/relationships" xmlns:p="http://schemas.openxmlformats.org/presentationml/2006/main">
   <p:cSld>
     <p:spTree>
       <p:nvGrpSpPr>
@@ -8010,7 +7982,14 @@
         <p:cNvGrpSpPr/>
         <p:nvPr/>
       </p:nvGrpSpPr>
-      <p:grpSpPr/>
+      <p:grpSpPr>
+        <a:xfrm>
+          <a:off x="0" y="0"/>
+          <a:ext cx="0" cy="0"/>
+          <a:chOff x="0" y="0"/>
+          <a:chExt cx="0" cy="0"/>
+        </a:xfrm>
+      </p:grpSpPr>
       <p:sp>
         <p:nvSpPr>
           <p:cNvPr id="2" name="TextBox 1"/>
@@ -8067,7 +8046,7 @@
           <p:nvPr/>
         </p:nvPicPr>
         <p:blipFill>
-          <a:blip r:embed="rId2"/>
+          <a:blip r:embed="rId3"/>
           <a:stretch>
             <a:fillRect/>
           </a:stretch>
@@ -8124,6 +8103,7 @@
           <a:lstStyle/>
           <a:p>
             <a:pPr algn="ctr"/>
+            <a:endParaRPr/>
           </a:p>
         </p:txBody>
       </p:sp>
@@ -8231,7 +8211,7 @@
 </file>
 
 <file path=ppt/slides/slide8.xml><?xml version="1.0" encoding="utf-8"?>
-<p:sld xmlns:a="http://schemas.openxmlformats.org/drawingml/2006/main" xmlns:p="http://schemas.openxmlformats.org/presentationml/2006/main" xmlns:r="http://schemas.openxmlformats.org/officeDocument/2006/relationships">
+<p:sld xmlns:a="http://schemas.openxmlformats.org/drawingml/2006/main" xmlns:r="http://schemas.openxmlformats.org/officeDocument/2006/relationships" xmlns:p="http://schemas.openxmlformats.org/presentationml/2006/main">
   <p:cSld>
     <p:spTree>
       <p:nvGrpSpPr>
@@ -8239,7 +8219,14 @@
         <p:cNvGrpSpPr/>
         <p:nvPr/>
       </p:nvGrpSpPr>
-      <p:grpSpPr/>
+      <p:grpSpPr>
+        <a:xfrm>
+          <a:off x="0" y="0"/>
+          <a:ext cx="0" cy="0"/>
+          <a:chOff x="0" y="0"/>
+          <a:chExt cx="0" cy="0"/>
+        </a:xfrm>
+      </p:grpSpPr>
       <p:sp>
         <p:nvSpPr>
           <p:cNvPr id="2" name="TextBox 1"/>
@@ -8296,7 +8283,7 @@
           <p:nvPr/>
         </p:nvPicPr>
         <p:blipFill>
-          <a:blip r:embed="rId2"/>
+          <a:blip r:embed="rId3"/>
           <a:stretch>
             <a:fillRect/>
           </a:stretch>
@@ -8353,6 +8340,7 @@
           <a:lstStyle/>
           <a:p>
             <a:pPr algn="ctr"/>
+            <a:endParaRPr/>
           </a:p>
         </p:txBody>
       </p:sp>
@@ -8445,7 +8433,7 @@
 </file>
 
 <file path=ppt/slides/slide9.xml><?xml version="1.0" encoding="utf-8"?>
-<p:sld xmlns:a="http://schemas.openxmlformats.org/drawingml/2006/main" xmlns:p="http://schemas.openxmlformats.org/presentationml/2006/main" xmlns:r="http://schemas.openxmlformats.org/officeDocument/2006/relationships">
+<p:sld xmlns:a="http://schemas.openxmlformats.org/drawingml/2006/main" xmlns:r="http://schemas.openxmlformats.org/officeDocument/2006/relationships" xmlns:p="http://schemas.openxmlformats.org/presentationml/2006/main">
   <p:cSld>
     <p:spTree>
       <p:nvGrpSpPr>
@@ -8453,7 +8441,14 @@
         <p:cNvGrpSpPr/>
         <p:nvPr/>
       </p:nvGrpSpPr>
-      <p:grpSpPr/>
+      <p:grpSpPr>
+        <a:xfrm>
+          <a:off x="0" y="0"/>
+          <a:ext cx="0" cy="0"/>
+          <a:chOff x="0" y="0"/>
+          <a:chExt cx="0" cy="0"/>
+        </a:xfrm>
+      </p:grpSpPr>
       <p:sp>
         <p:nvSpPr>
           <p:cNvPr id="2" name="TextBox 1"/>
@@ -8510,7 +8505,7 @@
           <p:nvPr/>
         </p:nvPicPr>
         <p:blipFill>
-          <a:blip r:embed="rId2"/>
+          <a:blip r:embed="rId3"/>
           <a:stretch>
             <a:fillRect/>
           </a:stretch>
@@ -8567,6 +8562,7 @@
           <a:lstStyle/>
           <a:p>
             <a:pPr algn="ctr"/>
+            <a:endParaRPr/>
           </a:p>
         </p:txBody>
       </p:sp>
@@ -9004,44 +9000,44 @@
         <a:sysClr val="window" lastClr="FFFFFF"/>
       </a:lt1>
       <a:dk2>
-        <a:srgbClr val="1F497D"/>
+        <a:srgbClr val="44546A"/>
       </a:dk2>
       <a:lt2>
-        <a:srgbClr val="EEECE1"/>
+        <a:srgbClr val="E7E6E6"/>
       </a:lt2>
       <a:accent1>
-        <a:srgbClr val="4F81BD"/>
+        <a:srgbClr val="4472C4"/>
       </a:accent1>
       <a:accent2>
-        <a:srgbClr val="C0504D"/>
+        <a:srgbClr val="ED7D31"/>
       </a:accent2>
       <a:accent3>
-        <a:srgbClr val="9BBB59"/>
+        <a:srgbClr val="A5A5A5"/>
       </a:accent3>
       <a:accent4>
-        <a:srgbClr val="8064A2"/>
+        <a:srgbClr val="FFC000"/>
       </a:accent4>
       <a:accent5>
-        <a:srgbClr val="4BACC6"/>
+        <a:srgbClr val="5B9BD5"/>
       </a:accent5>
       <a:accent6>
-        <a:srgbClr val="F79646"/>
+        <a:srgbClr val="70AD47"/>
       </a:accent6>
       <a:hlink>
-        <a:srgbClr val="0000FF"/>
+        <a:srgbClr val="0563C1"/>
       </a:hlink>
       <a:folHlink>
-        <a:srgbClr val="800080"/>
+        <a:srgbClr val="954F72"/>
       </a:folHlink>
     </a:clrScheme>
     <a:fontScheme name="Office">
       <a:majorFont>
-        <a:latin typeface="Calibri"/>
+        <a:latin typeface="Calibri Light" panose="020F0302020204030204"/>
         <a:ea typeface=""/>
         <a:cs typeface=""/>
-        <a:font script="Jpan" typeface="ＭＳ Ｐゴシック"/>
+        <a:font script="Jpan" typeface="游ゴシック Light"/>
         <a:font script="Hang" typeface="맑은 고딕"/>
-        <a:font script="Hans" typeface="宋体"/>
+        <a:font script="Hans" typeface="等线 Light"/>
         <a:font script="Hant" typeface="新細明體"/>
         <a:font script="Arab" typeface="Times New Roman"/>
         <a:font script="Hebr" typeface="Times New Roman"/>
@@ -9069,14 +9065,31 @@
         <a:font script="Viet" typeface="Times New Roman"/>
         <a:font script="Uigh" typeface="Microsoft Uighur"/>
         <a:font script="Geor" typeface="Sylfaen"/>
+        <a:font script="Armn" typeface="Arial"/>
+        <a:font script="Bugi" typeface="Leelawadee UI"/>
+        <a:font script="Bopo" typeface="Microsoft JhengHei"/>
+        <a:font script="Java" typeface="Javanese Text"/>
+        <a:font script="Lisu" typeface="Segoe UI"/>
+        <a:font script="Mymr" typeface="Myanmar Text"/>
+        <a:font script="Nkoo" typeface="Ebrima"/>
+        <a:font script="Olck" typeface="Nirmala UI"/>
+        <a:font script="Osma" typeface="Ebrima"/>
+        <a:font script="Phag" typeface="Phagspa"/>
+        <a:font script="Syrn" typeface="Estrangelo Edessa"/>
+        <a:font script="Syrj" typeface="Estrangelo Edessa"/>
+        <a:font script="Syre" typeface="Estrangelo Edessa"/>
+        <a:font script="Sora" typeface="Nirmala UI"/>
+        <a:font script="Tale" typeface="Microsoft Tai Le"/>
+        <a:font script="Talu" typeface="Microsoft New Tai Lue"/>
+        <a:font script="Tfng" typeface="Ebrima"/>
       </a:majorFont>
       <a:minorFont>
-        <a:latin typeface="Calibri"/>
+        <a:latin typeface="Calibri" panose="020F0502020204030204"/>
         <a:ea typeface=""/>
         <a:cs typeface=""/>
-        <a:font script="Jpan" typeface="ＭＳ Ｐゴシック"/>
+        <a:font script="Jpan" typeface="游ゴシック"/>
         <a:font script="Hang" typeface="맑은 고딕"/>
-        <a:font script="Hans" typeface="宋体"/>
+        <a:font script="Hans" typeface="等线"/>
         <a:font script="Hant" typeface="新細明體"/>
         <a:font script="Arab" typeface="Arial"/>
         <a:font script="Hebr" typeface="Arial"/>
@@ -9104,6 +9117,23 @@
         <a:font script="Viet" typeface="Arial"/>
         <a:font script="Uigh" typeface="Microsoft Uighur"/>
         <a:font script="Geor" typeface="Sylfaen"/>
+        <a:font script="Armn" typeface="Arial"/>
+        <a:font script="Bugi" typeface="Leelawadee UI"/>
+        <a:font script="Bopo" typeface="Microsoft JhengHei"/>
+        <a:font script="Java" typeface="Javanese Text"/>
+        <a:font script="Lisu" typeface="Segoe UI"/>
+        <a:font script="Mymr" typeface="Myanmar Text"/>
+        <a:font script="Nkoo" typeface="Ebrima"/>
+        <a:font script="Olck" typeface="Nirmala UI"/>
+        <a:font script="Osma" typeface="Ebrima"/>
+        <a:font script="Phag" typeface="Phagspa"/>
+        <a:font script="Syrn" typeface="Estrangelo Edessa"/>
+        <a:font script="Syrj" typeface="Estrangelo Edessa"/>
+        <a:font script="Syre" typeface="Estrangelo Edessa"/>
+        <a:font script="Sora" typeface="Nirmala UI"/>
+        <a:font script="Tale" typeface="Microsoft Tai Le"/>
+        <a:font script="Talu" typeface="Microsoft New Tai Lue"/>
+        <a:font script="Tfng" typeface="Ebrima"/>
       </a:minorFont>
     </a:fontScheme>
     <a:fmtScheme name="Office">
@@ -9115,200 +9145,141 @@
           <a:gsLst>
             <a:gs pos="0">
               <a:schemeClr val="phClr">
-                <a:tint val="50000"/>
-                <a:satMod val="300000"/>
+                <a:lumMod val="110000"/>
+                <a:satMod val="105000"/>
+                <a:tint val="67000"/>
               </a:schemeClr>
             </a:gs>
-            <a:gs pos="35000">
+            <a:gs pos="50000">
               <a:schemeClr val="phClr">
-                <a:tint val="37000"/>
-                <a:satMod val="300000"/>
+                <a:lumMod val="105000"/>
+                <a:satMod val="103000"/>
+                <a:tint val="73000"/>
               </a:schemeClr>
             </a:gs>
             <a:gs pos="100000">
               <a:schemeClr val="phClr">
-                <a:tint val="15000"/>
-                <a:satMod val="350000"/>
+                <a:lumMod val="105000"/>
+                <a:satMod val="109000"/>
+                <a:tint val="81000"/>
               </a:schemeClr>
             </a:gs>
           </a:gsLst>
-          <a:lin ang="16200000" scaled="1"/>
+          <a:lin ang="5400000" scaled="0"/>
         </a:gradFill>
         <a:gradFill rotWithShape="1">
           <a:gsLst>
             <a:gs pos="0">
               <a:schemeClr val="phClr">
-                <a:tint val="100000"/>
+                <a:satMod val="103000"/>
+                <a:lumMod val="102000"/>
+                <a:tint val="94000"/>
+              </a:schemeClr>
+            </a:gs>
+            <a:gs pos="50000">
+              <a:schemeClr val="phClr">
+                <a:satMod val="110000"/>
+                <a:lumMod val="100000"/>
                 <a:shade val="100000"/>
-                <a:satMod val="130000"/>
               </a:schemeClr>
             </a:gs>
             <a:gs pos="100000">
               <a:schemeClr val="phClr">
-                <a:tint val="50000"/>
-                <a:shade val="100000"/>
-                <a:satMod val="350000"/>
+                <a:lumMod val="99000"/>
+                <a:satMod val="120000"/>
+                <a:shade val="78000"/>
               </a:schemeClr>
             </a:gs>
           </a:gsLst>
-          <a:lin ang="16200000" scaled="0"/>
+          <a:lin ang="5400000" scaled="0"/>
         </a:gradFill>
       </a:fillStyleLst>
       <a:lnStyleLst>
-        <a:ln w="9525" cap="flat" cmpd="sng" algn="ctr">
-          <a:solidFill>
-            <a:schemeClr val="phClr">
-              <a:shade val="95000"/>
-              <a:satMod val="105000"/>
-            </a:schemeClr>
-          </a:solidFill>
-          <a:prstDash val="solid"/>
-        </a:ln>
-        <a:ln w="25400" cap="flat" cmpd="sng" algn="ctr">
+        <a:ln w="6350" cap="flat" cmpd="sng" algn="ctr">
           <a:solidFill>
             <a:schemeClr val="phClr"/>
           </a:solidFill>
           <a:prstDash val="solid"/>
+          <a:miter lim="800000"/>
         </a:ln>
-        <a:ln w="38100" cap="flat" cmpd="sng" algn="ctr">
+        <a:ln w="12700" cap="flat" cmpd="sng" algn="ctr">
           <a:solidFill>
             <a:schemeClr val="phClr"/>
           </a:solidFill>
           <a:prstDash val="solid"/>
+          <a:miter lim="800000"/>
+        </a:ln>
+        <a:ln w="19050" cap="flat" cmpd="sng" algn="ctr">
+          <a:solidFill>
+            <a:schemeClr val="phClr"/>
+          </a:solidFill>
+          <a:prstDash val="solid"/>
+          <a:miter lim="800000"/>
         </a:ln>
       </a:lnStyleLst>
       <a:effectStyleLst>
         <a:effectStyle>
+          <a:effectLst/>
+        </a:effectStyle>
+        <a:effectStyle>
+          <a:effectLst/>
+        </a:effectStyle>
+        <a:effectStyle>
           <a:effectLst>
-            <a:outerShdw blurRad="40000" dist="20000" dir="5400000" rotWithShape="0">
+            <a:outerShdw blurRad="57150" dist="19050" dir="5400000" algn="ctr" rotWithShape="0">
               <a:srgbClr val="000000">
-                <a:alpha val="38000"/>
+                <a:alpha val="63000"/>
               </a:srgbClr>
             </a:outerShdw>
           </a:effectLst>
-        </a:effectStyle>
-        <a:effectStyle>
-          <a:effectLst>
-            <a:outerShdw blurRad="40000" dist="23000" dir="5400000" rotWithShape="0">
-              <a:srgbClr val="000000">
-                <a:alpha val="35000"/>
-              </a:srgbClr>
-            </a:outerShdw>
-          </a:effectLst>
-        </a:effectStyle>
-        <a:effectStyle>
-          <a:effectLst>
-            <a:outerShdw blurRad="40000" dist="23000" dir="5400000" rotWithShape="0">
-              <a:srgbClr val="000000">
-                <a:alpha val="35000"/>
-              </a:srgbClr>
-            </a:outerShdw>
-          </a:effectLst>
-          <a:scene3d>
-            <a:camera prst="orthographicFront">
-              <a:rot lat="0" lon="0" rev="0"/>
-            </a:camera>
-            <a:lightRig rig="threePt" dir="t">
-              <a:rot lat="0" lon="0" rev="1200000"/>
-            </a:lightRig>
-          </a:scene3d>
-          <a:sp3d>
-            <a:bevelT w="63500" h="25400"/>
-          </a:sp3d>
         </a:effectStyle>
       </a:effectStyleLst>
       <a:bgFillStyleLst>
         <a:solidFill>
           <a:schemeClr val="phClr"/>
         </a:solidFill>
+        <a:solidFill>
+          <a:schemeClr val="phClr">
+            <a:tint val="95000"/>
+            <a:satMod val="170000"/>
+          </a:schemeClr>
+        </a:solidFill>
         <a:gradFill rotWithShape="1">
           <a:gsLst>
             <a:gs pos="0">
               <a:schemeClr val="phClr">
-                <a:tint val="40000"/>
-                <a:satMod val="350000"/>
+                <a:tint val="93000"/>
+                <a:satMod val="150000"/>
+                <a:shade val="98000"/>
+                <a:lumMod val="102000"/>
               </a:schemeClr>
             </a:gs>
-            <a:gs pos="40000">
+            <a:gs pos="50000">
               <a:schemeClr val="phClr">
-                <a:tint val="45000"/>
-                <a:shade val="99000"/>
-                <a:satMod val="350000"/>
+                <a:tint val="98000"/>
+                <a:satMod val="130000"/>
+                <a:shade val="90000"/>
+                <a:lumMod val="103000"/>
               </a:schemeClr>
             </a:gs>
             <a:gs pos="100000">
               <a:schemeClr val="phClr">
-                <a:shade val="20000"/>
-                <a:satMod val="255000"/>
+                <a:shade val="63000"/>
+                <a:satMod val="120000"/>
               </a:schemeClr>
             </a:gs>
           </a:gsLst>
-          <a:path path="circle">
-            <a:fillToRect l="50000" t="-80000" r="50000" b="180000"/>
-          </a:path>
-        </a:gradFill>
-        <a:gradFill rotWithShape="1">
-          <a:gsLst>
-            <a:gs pos="0">
-              <a:schemeClr val="phClr">
-                <a:tint val="80000"/>
-                <a:satMod val="300000"/>
-              </a:schemeClr>
-            </a:gs>
-            <a:gs pos="100000">
-              <a:schemeClr val="phClr">
-                <a:shade val="30000"/>
-                <a:satMod val="200000"/>
-              </a:schemeClr>
-            </a:gs>
-          </a:gsLst>
-          <a:path path="circle">
-            <a:fillToRect l="50000" t="50000" r="50000" b="50000"/>
-          </a:path>
+          <a:lin ang="5400000" scaled="0"/>
         </a:gradFill>
       </a:bgFillStyleLst>
     </a:fmtScheme>
   </a:themeElements>
-  <a:objectDefaults>
-    <a:spDef>
-      <a:spPr/>
-      <a:bodyPr/>
-      <a:lstStyle/>
-      <a:style>
-        <a:lnRef idx="1">
-          <a:schemeClr val="accent1"/>
-        </a:lnRef>
-        <a:fillRef idx="3">
-          <a:schemeClr val="accent1"/>
-        </a:fillRef>
-        <a:effectRef idx="2">
-          <a:schemeClr val="accent1"/>
-        </a:effectRef>
-        <a:fontRef idx="minor">
-          <a:schemeClr val="lt1"/>
-        </a:fontRef>
-      </a:style>
-    </a:spDef>
-    <a:lnDef>
-      <a:spPr/>
-      <a:bodyPr/>
-      <a:lstStyle/>
-      <a:style>
-        <a:lnRef idx="2">
-          <a:schemeClr val="accent1"/>
-        </a:lnRef>
-        <a:fillRef idx="0">
-          <a:schemeClr val="accent1"/>
-        </a:fillRef>
-        <a:effectRef idx="1">
-          <a:schemeClr val="accent1"/>
-        </a:effectRef>
-        <a:fontRef idx="minor">
-          <a:schemeClr val="tx1"/>
-        </a:fontRef>
-      </a:style>
-    </a:lnDef>
-  </a:objectDefaults>
+  <a:objectDefaults/>
   <a:extraClrSchemeLst/>
+  <a:extLst>
+    <a:ext uri="{05A4C25C-085E-4340-85A3-A5531E510DB2}">
+      <thm15:themeFamily xmlns:thm15="http://schemas.microsoft.com/office/thememl/2012/main" name="Office Theme" id="{62F939B6-93AF-4DB8-9C6B-D6C7DFDC589F}" vid="{4A3C46E8-61CC-4603-A589-7422A47A8E4A}"/>
+    </a:ext>
+  </a:extLst>
 </a:theme>
 </file>
</xml_diff>